<commit_message>
feat: add stage admission and refine course materials
</commit_message>
<xml_diff>
--- a/odevzdani/cviceni-03-prototyp/prezentace.pptx
+++ b/odevzdani/cviceni-03-prototyp/prezentace.pptx
@@ -3878,7 +3878,7 @@
             <a:avLst/>
           </a:prstGeom>
           <a:solidFill>
-            <a:srgbClr val="FFFFFF"/>
+            <a:srgbClr val="101217"/>
           </a:solidFill>
           <a:ln>
             <a:noFill/>
@@ -3914,14 +3914,14 @@
         </p:nvSpPr>
         <p:spPr>
           <a:xfrm>
-            <a:off x="711200" y="609600"/>
-            <a:ext cx="76200" cy="381000"/>
+            <a:off x="0" y="0"/>
+            <a:ext cx="152400" cy="6858000"/>
           </a:xfrm>
           <a:prstGeom prst="rect">
             <a:avLst/>
           </a:prstGeom>
           <a:solidFill>
-            <a:srgbClr val="E55024"/>
+            <a:srgbClr val="FF885D"/>
           </a:solidFill>
           <a:ln>
             <a:noFill/>
@@ -3951,56 +3951,100 @@
       </p:sp>
       <p:sp>
         <p:nvSpPr>
-          <p:cNvPr id="4" name="TextBox 3"/>
+          <p:cNvPr id="4" name="Rectangle 3"/>
+          <p:cNvSpPr/>
+          <p:nvPr/>
+        </p:nvSpPr>
+        <p:spPr>
+          <a:xfrm>
+            <a:off x="8255000" y="0"/>
+            <a:ext cx="3937000" cy="6858000"/>
+          </a:xfrm>
+          <a:prstGeom prst="rect">
+            <a:avLst/>
+          </a:prstGeom>
+          <a:solidFill>
+            <a:srgbClr val="1D222C"/>
+          </a:solidFill>
+          <a:ln>
+            <a:noFill/>
+          </a:ln>
+        </p:spPr>
+        <p:style>
+          <a:lnRef idx="1">
+            <a:schemeClr val="accent1"/>
+          </a:lnRef>
+          <a:fillRef idx="3">
+            <a:schemeClr val="accent1"/>
+          </a:fillRef>
+          <a:effectRef idx="2">
+            <a:schemeClr val="accent1"/>
+          </a:effectRef>
+          <a:fontRef idx="minor">
+            <a:schemeClr val="lt1"/>
+          </a:fontRef>
+        </p:style>
+        <p:txBody>
+          <a:bodyPr rtlCol="0" anchor="ctr"/>
+          <a:lstStyle/>
+          <a:p>
+            <a:pPr algn="ctr"/>
+          </a:p>
+        </p:txBody>
+      </p:sp>
+      <p:sp>
+        <p:nvSpPr>
+          <p:cNvPr id="5" name="Rectangle 4"/>
+          <p:cNvSpPr/>
+          <p:nvPr/>
+        </p:nvSpPr>
+        <p:spPr>
+          <a:xfrm>
+            <a:off x="8255000" y="0"/>
+            <a:ext cx="3937000" cy="101600"/>
+          </a:xfrm>
+          <a:prstGeom prst="rect">
+            <a:avLst/>
+          </a:prstGeom>
+          <a:solidFill>
+            <a:srgbClr val="FF885D"/>
+          </a:solidFill>
+          <a:ln>
+            <a:noFill/>
+          </a:ln>
+        </p:spPr>
+        <p:style>
+          <a:lnRef idx="1">
+            <a:schemeClr val="accent1"/>
+          </a:lnRef>
+          <a:fillRef idx="3">
+            <a:schemeClr val="accent1"/>
+          </a:fillRef>
+          <a:effectRef idx="2">
+            <a:schemeClr val="accent1"/>
+          </a:effectRef>
+          <a:fontRef idx="minor">
+            <a:schemeClr val="lt1"/>
+          </a:fontRef>
+        </p:style>
+        <p:txBody>
+          <a:bodyPr rtlCol="0" anchor="ctr"/>
+          <a:lstStyle/>
+          <a:p>
+            <a:pPr algn="ctr"/>
+          </a:p>
+        </p:txBody>
+      </p:sp>
+      <p:sp>
+        <p:nvSpPr>
+          <p:cNvPr id="6" name="TextBox 5"/>
           <p:cNvSpPr txBox="1"/>
           <p:nvPr/>
         </p:nvSpPr>
         <p:spPr>
           <a:xfrm>
-            <a:off x="977900" y="647700"/>
-            <a:ext cx="10502900" cy="317500"/>
-          </a:xfrm>
-          <a:prstGeom prst="rect">
-            <a:avLst/>
-          </a:prstGeom>
-          <a:noFill/>
-        </p:spPr>
-        <p:txBody>
-          <a:bodyPr wrap="none" lIns="0" rIns="0" tIns="0" bIns="0">
-            <a:noAutofit/>
-          </a:bodyPr>
-          <a:lstStyle/>
-          <a:p>
-            <a:pPr>
-              <a:lnSpc>
-                <a:spcPts val="2360"/>
-              </a:lnSpc>
-              <a:spcAft>
-                <a:spcPts val="0"/>
-              </a:spcAft>
-              <a:defRPr sz="2000" b="1">
-                <a:solidFill>
-                  <a:srgbClr val="191B20"/>
-                </a:solidFill>
-                <a:latin typeface="Arial"/>
-              </a:defRPr>
-            </a:pPr>
-            <a:r>
-              <a:t>PRAGUE PULSE FEST</a:t>
-            </a:r>
-          </a:p>
-        </p:txBody>
-      </p:sp>
-      <p:sp>
-        <p:nvSpPr>
-          <p:cNvPr id="5" name="TextBox 4"/>
-          <p:cNvSpPr txBox="1"/>
-          <p:nvPr/>
-        </p:nvSpPr>
-        <p:spPr>
-          <a:xfrm>
-            <a:off x="711200" y="1600200"/>
-            <a:ext cx="10769600" cy="241300"/>
+            <a:off x="609600" y="546100"/>
+            <a:ext cx="10972800" cy="304800"/>
           </a:xfrm>
           <a:prstGeom prst="rect">
             <a:avLst/>
@@ -4022,7 +4066,7 @@
               </a:spcAft>
               <a:defRPr sz="1400" b="1">
                 <a:solidFill>
-                  <a:srgbClr val="E55024"/>
+                  <a:srgbClr val="FF885D"/>
                 </a:solidFill>
                 <a:latin typeface="Arial"/>
               </a:defRPr>
@@ -4035,14 +4079,14 @@
       </p:sp>
       <p:sp>
         <p:nvSpPr>
-          <p:cNvPr id="6" name="TextBox 5"/>
+          <p:cNvPr id="7" name="TextBox 6"/>
           <p:cNvSpPr txBox="1"/>
           <p:nvPr/>
         </p:nvSpPr>
         <p:spPr>
           <a:xfrm>
-            <a:off x="685800" y="2146300"/>
-            <a:ext cx="10795000" cy="1816100"/>
+            <a:off x="571500" y="1193800"/>
+            <a:ext cx="10985500" cy="1879600"/>
           </a:xfrm>
           <a:prstGeom prst="rect">
             <a:avLst/>
@@ -4057,19 +4101,80 @@
           <a:p>
             <a:pPr>
               <a:lnSpc>
-                <a:spcPts val="5376"/>
+                <a:spcPts val="6467"/>
               </a:lnSpc>
               <a:spcAft>
                 <a:spcPts val="0"/>
               </a:spcAft>
-              <a:defRPr sz="4800" b="1">
+              <a:defRPr sz="6600" b="1">
                 <a:solidFill>
-                  <a:srgbClr val="191B20"/>
+                  <a:srgbClr val="F5F6FA"/>
                 </a:solidFill>
                 <a:latin typeface="Arial"/>
               </a:defRPr>
             </a:pPr>
             <a:r>
+              <a:t>PRAGUE</a:t>
+            </a:r>
+          </a:p>
+          <a:p>
+            <a:pPr>
+              <a:lnSpc>
+                <a:spcPts val="6467"/>
+              </a:lnSpc>
+              <a:spcAft>
+                <a:spcPts val="0"/>
+              </a:spcAft>
+              <a:defRPr sz="6600" b="1">
+                <a:solidFill>
+                  <a:srgbClr val="F5F6FA"/>
+                </a:solidFill>
+                <a:latin typeface="Arial"/>
+              </a:defRPr>
+            </a:pPr>
+            <a:r>
+              <a:t>PULSE FEST</a:t>
+            </a:r>
+          </a:p>
+        </p:txBody>
+      </p:sp>
+      <p:sp>
+        <p:nvSpPr>
+          <p:cNvPr id="8" name="TextBox 7"/>
+          <p:cNvSpPr txBox="1"/>
+          <p:nvPr/>
+        </p:nvSpPr>
+        <p:spPr>
+          <a:xfrm>
+            <a:off x="609600" y="3492500"/>
+            <a:ext cx="10858500" cy="1092200"/>
+          </a:xfrm>
+          <a:prstGeom prst="rect">
+            <a:avLst/>
+          </a:prstGeom>
+          <a:noFill/>
+        </p:spPr>
+        <p:txBody>
+          <a:bodyPr wrap="none" lIns="0" rIns="0" tIns="0" bIns="0">
+            <a:noAutofit/>
+          </a:bodyPr>
+          <a:lstStyle/>
+          <a:p>
+            <a:pPr>
+              <a:lnSpc>
+                <a:spcPts val="4028"/>
+              </a:lnSpc>
+              <a:spcAft>
+                <a:spcPts val="0"/>
+              </a:spcAft>
+              <a:defRPr sz="3800" b="1">
+                <a:solidFill>
+                  <a:srgbClr val="FF885D"/>
+                </a:solidFill>
+                <a:latin typeface="Arial"/>
+              </a:defRPr>
+            </a:pPr>
+            <a:r>
               <a:t>UX návrh a prototyp</a:t>
             </a:r>
           </a:p>
@@ -4077,14 +4182,14 @@
       </p:sp>
       <p:sp>
         <p:nvSpPr>
-          <p:cNvPr id="7" name="TextBox 6"/>
+          <p:cNvPr id="9" name="TextBox 8"/>
           <p:cNvSpPr txBox="1"/>
           <p:nvPr/>
         </p:nvSpPr>
         <p:spPr>
           <a:xfrm>
-            <a:off x="711200" y="4191000"/>
-            <a:ext cx="10769600" cy="1016000"/>
+            <a:off x="609600" y="4889500"/>
+            <a:ext cx="10858500" cy="825500"/>
           </a:xfrm>
           <a:prstGeom prst="rect">
             <a:avLst/>
@@ -4106,7 +4211,7 @@
               </a:spcAft>
               <a:defRPr sz="2300" b="0">
                 <a:solidFill>
-                  <a:srgbClr val="626773"/>
+                  <a:srgbClr val="B7BFCC"/>
                 </a:solidFill>
                 <a:latin typeface="Arial"/>
               </a:defRPr>
@@ -4125,7 +4230,7 @@
               </a:spcAft>
               <a:defRPr sz="2300" b="0">
                 <a:solidFill>
-                  <a:srgbClr val="626773"/>
+                  <a:srgbClr val="B7BFCC"/>
                 </a:solidFill>
                 <a:latin typeface="Arial"/>
               </a:defRPr>
@@ -4138,14 +4243,14 @@
       </p:sp>
       <p:sp>
         <p:nvSpPr>
-          <p:cNvPr id="8" name="TextBox 7"/>
+          <p:cNvPr id="10" name="TextBox 9"/>
           <p:cNvSpPr txBox="1"/>
           <p:nvPr/>
         </p:nvSpPr>
         <p:spPr>
           <a:xfrm>
-            <a:off x="711200" y="5600700"/>
-            <a:ext cx="10769600" cy="304800"/>
+            <a:off x="609600" y="5880100"/>
+            <a:ext cx="10972800" cy="330200"/>
           </a:xfrm>
           <a:prstGeom prst="rect">
             <a:avLst/>
@@ -4160,14 +4265,14 @@
           <a:p>
             <a:pPr>
               <a:lnSpc>
-                <a:spcPts val="2242"/>
+                <a:spcPts val="2124"/>
               </a:lnSpc>
               <a:spcAft>
                 <a:spcPts val="0"/>
               </a:spcAft>
-              <a:defRPr sz="1900" b="0">
+              <a:defRPr sz="1800" b="0">
                 <a:solidFill>
-                  <a:srgbClr val="191B20"/>
+                  <a:srgbClr val="F5F6FA"/>
                 </a:solidFill>
                 <a:latin typeface="Arial"/>
               </a:defRPr>
@@ -4180,20 +4285,20 @@
       </p:sp>
       <p:sp>
         <p:nvSpPr>
-          <p:cNvPr id="9" name="Rectangle 8"/>
+          <p:cNvPr id="11" name="Rectangle 10"/>
           <p:cNvSpPr/>
           <p:nvPr/>
         </p:nvSpPr>
         <p:spPr>
           <a:xfrm>
-            <a:off x="711200" y="6248400"/>
-            <a:ext cx="10769600" cy="12700"/>
+            <a:off x="609600" y="6273800"/>
+            <a:ext cx="10972800" cy="12700"/>
           </a:xfrm>
           <a:prstGeom prst="rect">
             <a:avLst/>
           </a:prstGeom>
           <a:solidFill>
-            <a:srgbClr val="DFE2E7"/>
+            <a:srgbClr val="3D4552"/>
           </a:solidFill>
           <a:ln>
             <a:noFill/>
@@ -4223,14 +4328,14 @@
       </p:sp>
       <p:sp>
         <p:nvSpPr>
-          <p:cNvPr id="10" name="TextBox 9"/>
+          <p:cNvPr id="12" name="TextBox 11"/>
           <p:cNvSpPr txBox="1"/>
           <p:nvPr/>
         </p:nvSpPr>
         <p:spPr>
           <a:xfrm>
-            <a:off x="711200" y="6438900"/>
-            <a:ext cx="9652000" cy="203200"/>
+            <a:off x="609600" y="6464300"/>
+            <a:ext cx="9906000" cy="203200"/>
           </a:xfrm>
           <a:prstGeom prst="rect">
             <a:avLst/>
@@ -4252,7 +4357,7 @@
               </a:spcAft>
               <a:defRPr sz="1100" b="0">
                 <a:solidFill>
-                  <a:srgbClr val="626773"/>
+                  <a:srgbClr val="B7BFCC"/>
                 </a:solidFill>
                 <a:latin typeface="Arial"/>
               </a:defRPr>
@@ -4265,14 +4370,14 @@
       </p:sp>
       <p:sp>
         <p:nvSpPr>
-          <p:cNvPr id="11" name="TextBox 10"/>
+          <p:cNvPr id="13" name="TextBox 12"/>
           <p:cNvSpPr txBox="1"/>
           <p:nvPr/>
         </p:nvSpPr>
         <p:spPr>
           <a:xfrm>
-            <a:off x="10807700" y="6413500"/>
-            <a:ext cx="673100" cy="215900"/>
+            <a:off x="10972800" y="6438900"/>
+            <a:ext cx="609600" cy="215900"/>
           </a:xfrm>
           <a:prstGeom prst="rect">
             <a:avLst/>
@@ -4294,7 +4399,7 @@
               </a:spcAft>
               <a:defRPr sz="1200" b="0">
                 <a:solidFill>
-                  <a:srgbClr val="626773"/>
+                  <a:srgbClr val="B7BFCC"/>
                 </a:solidFill>
                 <a:latin typeface="Arial"/>
               </a:defRPr>
@@ -4338,7 +4443,7 @@
             <a:avLst/>
           </a:prstGeom>
           <a:solidFill>
-            <a:srgbClr val="FFFFFF"/>
+            <a:srgbClr val="101217"/>
           </a:solidFill>
           <a:ln>
             <a:noFill/>
@@ -4368,14 +4473,57 @@
       </p:sp>
       <p:sp>
         <p:nvSpPr>
-          <p:cNvPr id="3" name="TextBox 2"/>
+          <p:cNvPr id="3" name="Rectangle 2"/>
+          <p:cNvSpPr/>
+          <p:nvPr/>
+        </p:nvSpPr>
+        <p:spPr>
+          <a:xfrm>
+            <a:off x="0" y="0"/>
+            <a:ext cx="101600" cy="6858000"/>
+          </a:xfrm>
+          <a:prstGeom prst="rect">
+            <a:avLst/>
+          </a:prstGeom>
+          <a:solidFill>
+            <a:srgbClr val="FF885D"/>
+          </a:solidFill>
+          <a:ln>
+            <a:noFill/>
+          </a:ln>
+        </p:spPr>
+        <p:style>
+          <a:lnRef idx="1">
+            <a:schemeClr val="accent1"/>
+          </a:lnRef>
+          <a:fillRef idx="3">
+            <a:schemeClr val="accent1"/>
+          </a:fillRef>
+          <a:effectRef idx="2">
+            <a:schemeClr val="accent1"/>
+          </a:effectRef>
+          <a:fontRef idx="minor">
+            <a:schemeClr val="lt1"/>
+          </a:fontRef>
+        </p:style>
+        <p:txBody>
+          <a:bodyPr rtlCol="0" anchor="ctr"/>
+          <a:lstStyle/>
+          <a:p>
+            <a:pPr algn="ctr"/>
+          </a:p>
+        </p:txBody>
+      </p:sp>
+      <p:sp>
+        <p:nvSpPr>
+          <p:cNvPr id="4" name="TextBox 3"/>
           <p:cNvSpPr txBox="1"/>
           <p:nvPr/>
         </p:nvSpPr>
         <p:spPr>
           <a:xfrm>
-            <a:off x="711200" y="457200"/>
-            <a:ext cx="10769600" cy="228600"/>
+            <a:off x="609600" y="444500"/>
+            <a:ext cx="10972800" cy="279400"/>
           </a:xfrm>
           <a:prstGeom prst="rect">
             <a:avLst/>
@@ -4397,7 +4545,7 @@
               </a:spcAft>
               <a:defRPr sz="1300" b="1">
                 <a:solidFill>
-                  <a:srgbClr val="626773"/>
+                  <a:srgbClr val="B7BFCC"/>
                 </a:solidFill>
                 <a:latin typeface="Arial"/>
               </a:defRPr>
@@ -4410,20 +4558,20 @@
       </p:sp>
       <p:sp>
         <p:nvSpPr>
-          <p:cNvPr id="4" name="Rectangle 3"/>
+          <p:cNvPr id="5" name="Rectangle 4"/>
           <p:cNvSpPr/>
           <p:nvPr/>
         </p:nvSpPr>
         <p:spPr>
           <a:xfrm>
-            <a:off x="711200" y="876300"/>
-            <a:ext cx="622300" cy="50800"/>
+            <a:off x="609600" y="876300"/>
+            <a:ext cx="685800" cy="50800"/>
           </a:xfrm>
           <a:prstGeom prst="rect">
             <a:avLst/>
           </a:prstGeom>
           <a:solidFill>
-            <a:srgbClr val="E55024"/>
+            <a:srgbClr val="FF885D"/>
           </a:solidFill>
           <a:ln>
             <a:noFill/>
@@ -4453,14 +4601,14 @@
       </p:sp>
       <p:sp>
         <p:nvSpPr>
-          <p:cNvPr id="5" name="TextBox 4"/>
+          <p:cNvPr id="6" name="TextBox 5"/>
           <p:cNvSpPr txBox="1"/>
           <p:nvPr/>
         </p:nvSpPr>
         <p:spPr>
           <a:xfrm>
-            <a:off x="685800" y="1257300"/>
-            <a:ext cx="10795000" cy="1168400"/>
+            <a:off x="584200" y="1206500"/>
+            <a:ext cx="10998200" cy="1130300"/>
           </a:xfrm>
           <a:prstGeom prst="rect">
             <a:avLst/>
@@ -4482,7 +4630,7 @@
               </a:spcAft>
               <a:defRPr sz="3600" b="1">
                 <a:solidFill>
-                  <a:srgbClr val="191B20"/>
+                  <a:srgbClr val="F5F6FA"/>
                 </a:solidFill>
                 <a:latin typeface="Arial"/>
               </a:defRPr>
@@ -4495,20 +4643,20 @@
       </p:sp>
       <p:sp>
         <p:nvSpPr>
-          <p:cNvPr id="6" name="Rectangle 5"/>
+          <p:cNvPr id="7" name="Rectangle 6"/>
           <p:cNvSpPr/>
           <p:nvPr/>
         </p:nvSpPr>
         <p:spPr>
           <a:xfrm>
-            <a:off x="723900" y="2273300"/>
+            <a:off x="711200" y="2336800"/>
             <a:ext cx="101600" cy="101600"/>
           </a:xfrm>
           <a:prstGeom prst="rect">
             <a:avLst/>
           </a:prstGeom>
           <a:solidFill>
-            <a:srgbClr val="E55024"/>
+            <a:srgbClr val="FF885D"/>
           </a:solidFill>
           <a:ln>
             <a:noFill/>
@@ -4538,13 +4686,13 @@
       </p:sp>
       <p:sp>
         <p:nvSpPr>
-          <p:cNvPr id="7" name="TextBox 6"/>
+          <p:cNvPr id="8" name="TextBox 7"/>
           <p:cNvSpPr txBox="1"/>
           <p:nvPr/>
         </p:nvSpPr>
         <p:spPr>
           <a:xfrm>
-            <a:off x="1066800" y="2146300"/>
+            <a:off x="1066800" y="2209800"/>
             <a:ext cx="10160000" cy="419100"/>
           </a:xfrm>
           <a:prstGeom prst="rect">
@@ -4567,7 +4715,7 @@
               </a:spcAft>
               <a:defRPr sz="2800" b="0">
                 <a:solidFill>
-                  <a:srgbClr val="191B20"/>
+                  <a:srgbClr val="F5F6FA"/>
                 </a:solidFill>
                 <a:latin typeface="Arial"/>
               </a:defRPr>
@@ -4580,20 +4728,20 @@
       </p:sp>
       <p:sp>
         <p:nvSpPr>
-          <p:cNvPr id="8" name="Rectangle 7"/>
+          <p:cNvPr id="9" name="Rectangle 8"/>
           <p:cNvSpPr/>
           <p:nvPr/>
         </p:nvSpPr>
         <p:spPr>
           <a:xfrm>
-            <a:off x="723900" y="2971800"/>
+            <a:off x="711200" y="3009900"/>
             <a:ext cx="101600" cy="101600"/>
           </a:xfrm>
           <a:prstGeom prst="rect">
             <a:avLst/>
           </a:prstGeom>
           <a:solidFill>
-            <a:srgbClr val="E55024"/>
+            <a:srgbClr val="FF885D"/>
           </a:solidFill>
           <a:ln>
             <a:noFill/>
@@ -4623,13 +4771,13 @@
       </p:sp>
       <p:sp>
         <p:nvSpPr>
-          <p:cNvPr id="9" name="TextBox 8"/>
+          <p:cNvPr id="10" name="TextBox 9"/>
           <p:cNvSpPr txBox="1"/>
           <p:nvPr/>
         </p:nvSpPr>
         <p:spPr>
           <a:xfrm>
-            <a:off x="1066800" y="2844800"/>
+            <a:off x="1066800" y="2882900"/>
             <a:ext cx="10160000" cy="419100"/>
           </a:xfrm>
           <a:prstGeom prst="rect">
@@ -4652,7 +4800,7 @@
               </a:spcAft>
               <a:defRPr sz="2800" b="0">
                 <a:solidFill>
-                  <a:srgbClr val="191B20"/>
+                  <a:srgbClr val="F5F6FA"/>
                 </a:solidFill>
                 <a:latin typeface="Arial"/>
               </a:defRPr>
@@ -4665,20 +4813,20 @@
       </p:sp>
       <p:sp>
         <p:nvSpPr>
-          <p:cNvPr id="10" name="Rectangle 9"/>
+          <p:cNvPr id="11" name="Rectangle 10"/>
           <p:cNvSpPr/>
           <p:nvPr/>
         </p:nvSpPr>
         <p:spPr>
           <a:xfrm>
-            <a:off x="723900" y="3670300"/>
+            <a:off x="711200" y="3683000"/>
             <a:ext cx="101600" cy="101600"/>
           </a:xfrm>
           <a:prstGeom prst="rect">
             <a:avLst/>
           </a:prstGeom>
           <a:solidFill>
-            <a:srgbClr val="E55024"/>
+            <a:srgbClr val="FF885D"/>
           </a:solidFill>
           <a:ln>
             <a:noFill/>
@@ -4708,13 +4856,13 @@
       </p:sp>
       <p:sp>
         <p:nvSpPr>
-          <p:cNvPr id="11" name="TextBox 10"/>
+          <p:cNvPr id="12" name="TextBox 11"/>
           <p:cNvSpPr txBox="1"/>
           <p:nvPr/>
         </p:nvSpPr>
         <p:spPr>
           <a:xfrm>
-            <a:off x="1066800" y="3543300"/>
+            <a:off x="1066800" y="3556000"/>
             <a:ext cx="10160000" cy="419100"/>
           </a:xfrm>
           <a:prstGeom prst="rect">
@@ -4737,7 +4885,7 @@
               </a:spcAft>
               <a:defRPr sz="2800" b="0">
                 <a:solidFill>
-                  <a:srgbClr val="191B20"/>
+                  <a:srgbClr val="F5F6FA"/>
                 </a:solidFill>
                 <a:latin typeface="Arial"/>
               </a:defRPr>
@@ -4750,20 +4898,20 @@
       </p:sp>
       <p:sp>
         <p:nvSpPr>
-          <p:cNvPr id="12" name="Rectangle 11"/>
+          <p:cNvPr id="13" name="Rectangle 12"/>
           <p:cNvSpPr/>
           <p:nvPr/>
         </p:nvSpPr>
         <p:spPr>
           <a:xfrm>
-            <a:off x="723900" y="4368800"/>
+            <a:off x="711200" y="4356100"/>
             <a:ext cx="101600" cy="101600"/>
           </a:xfrm>
           <a:prstGeom prst="rect">
             <a:avLst/>
           </a:prstGeom>
           <a:solidFill>
-            <a:srgbClr val="E55024"/>
+            <a:srgbClr val="FF885D"/>
           </a:solidFill>
           <a:ln>
             <a:noFill/>
@@ -4793,13 +4941,13 @@
       </p:sp>
       <p:sp>
         <p:nvSpPr>
-          <p:cNvPr id="13" name="TextBox 12"/>
+          <p:cNvPr id="14" name="TextBox 13"/>
           <p:cNvSpPr txBox="1"/>
           <p:nvPr/>
         </p:nvSpPr>
         <p:spPr>
           <a:xfrm>
-            <a:off x="1066800" y="4241800"/>
+            <a:off x="1066800" y="4229100"/>
             <a:ext cx="10160000" cy="419100"/>
           </a:xfrm>
           <a:prstGeom prst="rect">
@@ -4822,7 +4970,7 @@
               </a:spcAft>
               <a:defRPr sz="2800" b="0">
                 <a:solidFill>
-                  <a:srgbClr val="191B20"/>
+                  <a:srgbClr val="F5F6FA"/>
                 </a:solidFill>
                 <a:latin typeface="Arial"/>
               </a:defRPr>
@@ -4835,20 +4983,20 @@
       </p:sp>
       <p:sp>
         <p:nvSpPr>
-          <p:cNvPr id="14" name="Rectangle 13"/>
+          <p:cNvPr id="15" name="Rectangle 14"/>
           <p:cNvSpPr/>
           <p:nvPr/>
         </p:nvSpPr>
         <p:spPr>
           <a:xfrm>
-            <a:off x="711200" y="6248400"/>
-            <a:ext cx="10769600" cy="12700"/>
+            <a:off x="609600" y="6273800"/>
+            <a:ext cx="10972800" cy="12700"/>
           </a:xfrm>
           <a:prstGeom prst="rect">
             <a:avLst/>
           </a:prstGeom>
           <a:solidFill>
-            <a:srgbClr val="DFE2E7"/>
+            <a:srgbClr val="3D4552"/>
           </a:solidFill>
           <a:ln>
             <a:noFill/>
@@ -4878,14 +5026,14 @@
       </p:sp>
       <p:sp>
         <p:nvSpPr>
-          <p:cNvPr id="15" name="TextBox 14"/>
+          <p:cNvPr id="16" name="TextBox 15"/>
           <p:cNvSpPr txBox="1"/>
           <p:nvPr/>
         </p:nvSpPr>
         <p:spPr>
           <a:xfrm>
-            <a:off x="711200" y="6438900"/>
-            <a:ext cx="9652000" cy="203200"/>
+            <a:off x="609600" y="6464300"/>
+            <a:ext cx="9906000" cy="203200"/>
           </a:xfrm>
           <a:prstGeom prst="rect">
             <a:avLst/>
@@ -4907,7 +5055,7 @@
               </a:spcAft>
               <a:defRPr sz="1100" b="0">
                 <a:solidFill>
-                  <a:srgbClr val="626773"/>
+                  <a:srgbClr val="B7BFCC"/>
                 </a:solidFill>
                 <a:latin typeface="Arial"/>
               </a:defRPr>
@@ -4920,14 +5068,14 @@
       </p:sp>
       <p:sp>
         <p:nvSpPr>
-          <p:cNvPr id="16" name="TextBox 15"/>
+          <p:cNvPr id="17" name="TextBox 16"/>
           <p:cNvSpPr txBox="1"/>
           <p:nvPr/>
         </p:nvSpPr>
         <p:spPr>
           <a:xfrm>
-            <a:off x="10807700" y="6413500"/>
-            <a:ext cx="673100" cy="215900"/>
+            <a:off x="10972800" y="6438900"/>
+            <a:ext cx="609600" cy="215900"/>
           </a:xfrm>
           <a:prstGeom prst="rect">
             <a:avLst/>
@@ -4949,7 +5097,7 @@
               </a:spcAft>
               <a:defRPr sz="1200" b="0">
                 <a:solidFill>
-                  <a:srgbClr val="626773"/>
+                  <a:srgbClr val="B7BFCC"/>
                 </a:solidFill>
                 <a:latin typeface="Arial"/>
               </a:defRPr>
@@ -4993,7 +5141,7 @@
             <a:avLst/>
           </a:prstGeom>
           <a:solidFill>
-            <a:srgbClr val="FFFFFF"/>
+            <a:srgbClr val="101217"/>
           </a:solidFill>
           <a:ln>
             <a:noFill/>
@@ -5023,14 +5171,57 @@
       </p:sp>
       <p:sp>
         <p:nvSpPr>
-          <p:cNvPr id="3" name="TextBox 2"/>
+          <p:cNvPr id="3" name="Rectangle 2"/>
+          <p:cNvSpPr/>
+          <p:nvPr/>
+        </p:nvSpPr>
+        <p:spPr>
+          <a:xfrm>
+            <a:off x="0" y="0"/>
+            <a:ext cx="101600" cy="6858000"/>
+          </a:xfrm>
+          <a:prstGeom prst="rect">
+            <a:avLst/>
+          </a:prstGeom>
+          <a:solidFill>
+            <a:srgbClr val="FF885D"/>
+          </a:solidFill>
+          <a:ln>
+            <a:noFill/>
+          </a:ln>
+        </p:spPr>
+        <p:style>
+          <a:lnRef idx="1">
+            <a:schemeClr val="accent1"/>
+          </a:lnRef>
+          <a:fillRef idx="3">
+            <a:schemeClr val="accent1"/>
+          </a:fillRef>
+          <a:effectRef idx="2">
+            <a:schemeClr val="accent1"/>
+          </a:effectRef>
+          <a:fontRef idx="minor">
+            <a:schemeClr val="lt1"/>
+          </a:fontRef>
+        </p:style>
+        <p:txBody>
+          <a:bodyPr rtlCol="0" anchor="ctr"/>
+          <a:lstStyle/>
+          <a:p>
+            <a:pPr algn="ctr"/>
+          </a:p>
+        </p:txBody>
+      </p:sp>
+      <p:sp>
+        <p:nvSpPr>
+          <p:cNvPr id="4" name="TextBox 3"/>
           <p:cNvSpPr txBox="1"/>
           <p:nvPr/>
         </p:nvSpPr>
         <p:spPr>
           <a:xfrm>
-            <a:off x="711200" y="457200"/>
-            <a:ext cx="10769600" cy="228600"/>
+            <a:off x="609600" y="444500"/>
+            <a:ext cx="10972800" cy="279400"/>
           </a:xfrm>
           <a:prstGeom prst="rect">
             <a:avLst/>
@@ -5052,7 +5243,7 @@
               </a:spcAft>
               <a:defRPr sz="1300" b="1">
                 <a:solidFill>
-                  <a:srgbClr val="626773"/>
+                  <a:srgbClr val="B7BFCC"/>
                 </a:solidFill>
                 <a:latin typeface="Arial"/>
               </a:defRPr>
@@ -5065,20 +5256,20 @@
       </p:sp>
       <p:sp>
         <p:nvSpPr>
-          <p:cNvPr id="4" name="Rectangle 3"/>
+          <p:cNvPr id="5" name="Rectangle 4"/>
           <p:cNvSpPr/>
           <p:nvPr/>
         </p:nvSpPr>
         <p:spPr>
           <a:xfrm>
-            <a:off x="711200" y="876300"/>
-            <a:ext cx="622300" cy="50800"/>
+            <a:off x="609600" y="876300"/>
+            <a:ext cx="685800" cy="50800"/>
           </a:xfrm>
           <a:prstGeom prst="rect">
             <a:avLst/>
           </a:prstGeom>
           <a:solidFill>
-            <a:srgbClr val="E55024"/>
+            <a:srgbClr val="FF885D"/>
           </a:solidFill>
           <a:ln>
             <a:noFill/>
@@ -5108,14 +5299,14 @@
       </p:sp>
       <p:sp>
         <p:nvSpPr>
-          <p:cNvPr id="5" name="TextBox 4"/>
+          <p:cNvPr id="6" name="TextBox 5"/>
           <p:cNvSpPr txBox="1"/>
           <p:nvPr/>
         </p:nvSpPr>
         <p:spPr>
           <a:xfrm>
-            <a:off x="685800" y="1257300"/>
-            <a:ext cx="10795000" cy="1168400"/>
+            <a:off x="584200" y="1206500"/>
+            <a:ext cx="10998200" cy="1130300"/>
           </a:xfrm>
           <a:prstGeom prst="rect">
             <a:avLst/>
@@ -5137,7 +5328,7 @@
               </a:spcAft>
               <a:defRPr sz="3600" b="1">
                 <a:solidFill>
-                  <a:srgbClr val="191B20"/>
+                  <a:srgbClr val="F5F6FA"/>
                 </a:solidFill>
                 <a:latin typeface="Arial"/>
               </a:defRPr>
@@ -5150,20 +5341,20 @@
       </p:sp>
       <p:sp>
         <p:nvSpPr>
-          <p:cNvPr id="6" name="Rectangle 5"/>
+          <p:cNvPr id="7" name="Rectangle 6"/>
           <p:cNvSpPr/>
           <p:nvPr/>
         </p:nvSpPr>
         <p:spPr>
           <a:xfrm>
-            <a:off x="723900" y="2273300"/>
+            <a:off x="711200" y="2336800"/>
             <a:ext cx="101600" cy="101600"/>
           </a:xfrm>
           <a:prstGeom prst="rect">
             <a:avLst/>
           </a:prstGeom>
           <a:solidFill>
-            <a:srgbClr val="E55024"/>
+            <a:srgbClr val="FF885D"/>
           </a:solidFill>
           <a:ln>
             <a:noFill/>
@@ -5193,13 +5384,13 @@
       </p:sp>
       <p:sp>
         <p:nvSpPr>
-          <p:cNvPr id="7" name="TextBox 6"/>
+          <p:cNvPr id="8" name="TextBox 7"/>
           <p:cNvSpPr txBox="1"/>
           <p:nvPr/>
         </p:nvSpPr>
         <p:spPr>
           <a:xfrm>
-            <a:off x="1066800" y="2146300"/>
+            <a:off x="1066800" y="2209800"/>
             <a:ext cx="10160000" cy="419100"/>
           </a:xfrm>
           <a:prstGeom prst="rect">
@@ -5222,7 +5413,7 @@
               </a:spcAft>
               <a:defRPr sz="2800" b="0">
                 <a:solidFill>
-                  <a:srgbClr val="191B20"/>
+                  <a:srgbClr val="F5F6FA"/>
                 </a:solidFill>
                 <a:latin typeface="Arial"/>
               </a:defRPr>
@@ -5235,20 +5426,20 @@
       </p:sp>
       <p:sp>
         <p:nvSpPr>
-          <p:cNvPr id="8" name="Rectangle 7"/>
+          <p:cNvPr id="9" name="Rectangle 8"/>
           <p:cNvSpPr/>
           <p:nvPr/>
         </p:nvSpPr>
         <p:spPr>
           <a:xfrm>
-            <a:off x="723900" y="2971800"/>
+            <a:off x="711200" y="3009900"/>
             <a:ext cx="101600" cy="101600"/>
           </a:xfrm>
           <a:prstGeom prst="rect">
             <a:avLst/>
           </a:prstGeom>
           <a:solidFill>
-            <a:srgbClr val="E55024"/>
+            <a:srgbClr val="FF885D"/>
           </a:solidFill>
           <a:ln>
             <a:noFill/>
@@ -5278,13 +5469,13 @@
       </p:sp>
       <p:sp>
         <p:nvSpPr>
-          <p:cNvPr id="9" name="TextBox 8"/>
+          <p:cNvPr id="10" name="TextBox 9"/>
           <p:cNvSpPr txBox="1"/>
           <p:nvPr/>
         </p:nvSpPr>
         <p:spPr>
           <a:xfrm>
-            <a:off x="1066800" y="2844800"/>
+            <a:off x="1066800" y="2882900"/>
             <a:ext cx="10160000" cy="419100"/>
           </a:xfrm>
           <a:prstGeom prst="rect">
@@ -5307,7 +5498,7 @@
               </a:spcAft>
               <a:defRPr sz="2800" b="0">
                 <a:solidFill>
-                  <a:srgbClr val="191B20"/>
+                  <a:srgbClr val="F5F6FA"/>
                 </a:solidFill>
                 <a:latin typeface="Arial"/>
               </a:defRPr>
@@ -5320,20 +5511,20 @@
       </p:sp>
       <p:sp>
         <p:nvSpPr>
-          <p:cNvPr id="10" name="Rectangle 9"/>
+          <p:cNvPr id="11" name="Rectangle 10"/>
           <p:cNvSpPr/>
           <p:nvPr/>
         </p:nvSpPr>
         <p:spPr>
           <a:xfrm>
-            <a:off x="723900" y="3670300"/>
+            <a:off x="711200" y="3683000"/>
             <a:ext cx="101600" cy="101600"/>
           </a:xfrm>
           <a:prstGeom prst="rect">
             <a:avLst/>
           </a:prstGeom>
           <a:solidFill>
-            <a:srgbClr val="E55024"/>
+            <a:srgbClr val="FF885D"/>
           </a:solidFill>
           <a:ln>
             <a:noFill/>
@@ -5363,13 +5554,13 @@
       </p:sp>
       <p:sp>
         <p:nvSpPr>
-          <p:cNvPr id="11" name="TextBox 10"/>
+          <p:cNvPr id="12" name="TextBox 11"/>
           <p:cNvSpPr txBox="1"/>
           <p:nvPr/>
         </p:nvSpPr>
         <p:spPr>
           <a:xfrm>
-            <a:off x="1066800" y="3543300"/>
+            <a:off x="1066800" y="3556000"/>
             <a:ext cx="10160000" cy="419100"/>
           </a:xfrm>
           <a:prstGeom prst="rect">
@@ -5392,7 +5583,7 @@
               </a:spcAft>
               <a:defRPr sz="2800" b="0">
                 <a:solidFill>
-                  <a:srgbClr val="191B20"/>
+                  <a:srgbClr val="F5F6FA"/>
                 </a:solidFill>
                 <a:latin typeface="Arial"/>
               </a:defRPr>
@@ -5405,20 +5596,20 @@
       </p:sp>
       <p:sp>
         <p:nvSpPr>
-          <p:cNvPr id="12" name="Rectangle 11"/>
+          <p:cNvPr id="13" name="Rectangle 12"/>
           <p:cNvSpPr/>
           <p:nvPr/>
         </p:nvSpPr>
         <p:spPr>
           <a:xfrm>
-            <a:off x="711200" y="6248400"/>
-            <a:ext cx="10769600" cy="12700"/>
+            <a:off x="609600" y="6273800"/>
+            <a:ext cx="10972800" cy="12700"/>
           </a:xfrm>
           <a:prstGeom prst="rect">
             <a:avLst/>
           </a:prstGeom>
           <a:solidFill>
-            <a:srgbClr val="DFE2E7"/>
+            <a:srgbClr val="3D4552"/>
           </a:solidFill>
           <a:ln>
             <a:noFill/>
@@ -5448,14 +5639,14 @@
       </p:sp>
       <p:sp>
         <p:nvSpPr>
-          <p:cNvPr id="13" name="TextBox 12"/>
+          <p:cNvPr id="14" name="TextBox 13"/>
           <p:cNvSpPr txBox="1"/>
           <p:nvPr/>
         </p:nvSpPr>
         <p:spPr>
           <a:xfrm>
-            <a:off x="711200" y="6438900"/>
-            <a:ext cx="9652000" cy="203200"/>
+            <a:off x="609600" y="6464300"/>
+            <a:ext cx="9906000" cy="203200"/>
           </a:xfrm>
           <a:prstGeom prst="rect">
             <a:avLst/>
@@ -5477,7 +5668,7 @@
               </a:spcAft>
               <a:defRPr sz="1100" b="0">
                 <a:solidFill>
-                  <a:srgbClr val="626773"/>
+                  <a:srgbClr val="B7BFCC"/>
                 </a:solidFill>
                 <a:latin typeface="Arial"/>
               </a:defRPr>
@@ -5490,14 +5681,14 @@
       </p:sp>
       <p:sp>
         <p:nvSpPr>
-          <p:cNvPr id="14" name="TextBox 13"/>
+          <p:cNvPr id="15" name="TextBox 14"/>
           <p:cNvSpPr txBox="1"/>
           <p:nvPr/>
         </p:nvSpPr>
         <p:spPr>
           <a:xfrm>
-            <a:off x="10807700" y="6413500"/>
-            <a:ext cx="673100" cy="215900"/>
+            <a:off x="10972800" y="6438900"/>
+            <a:ext cx="609600" cy="215900"/>
           </a:xfrm>
           <a:prstGeom prst="rect">
             <a:avLst/>
@@ -5519,7 +5710,7 @@
               </a:spcAft>
               <a:defRPr sz="1200" b="0">
                 <a:solidFill>
-                  <a:srgbClr val="626773"/>
+                  <a:srgbClr val="B7BFCC"/>
                 </a:solidFill>
                 <a:latin typeface="Arial"/>
               </a:defRPr>
@@ -5563,7 +5754,7 @@
             <a:avLst/>
           </a:prstGeom>
           <a:solidFill>
-            <a:srgbClr val="FFFFFF"/>
+            <a:srgbClr val="101217"/>
           </a:solidFill>
           <a:ln>
             <a:noFill/>
@@ -5593,14 +5784,57 @@
       </p:sp>
       <p:sp>
         <p:nvSpPr>
-          <p:cNvPr id="3" name="TextBox 2"/>
+          <p:cNvPr id="3" name="Rectangle 2"/>
+          <p:cNvSpPr/>
+          <p:nvPr/>
+        </p:nvSpPr>
+        <p:spPr>
+          <a:xfrm>
+            <a:off x="0" y="0"/>
+            <a:ext cx="101600" cy="6858000"/>
+          </a:xfrm>
+          <a:prstGeom prst="rect">
+            <a:avLst/>
+          </a:prstGeom>
+          <a:solidFill>
+            <a:srgbClr val="FF885D"/>
+          </a:solidFill>
+          <a:ln>
+            <a:noFill/>
+          </a:ln>
+        </p:spPr>
+        <p:style>
+          <a:lnRef idx="1">
+            <a:schemeClr val="accent1"/>
+          </a:lnRef>
+          <a:fillRef idx="3">
+            <a:schemeClr val="accent1"/>
+          </a:fillRef>
+          <a:effectRef idx="2">
+            <a:schemeClr val="accent1"/>
+          </a:effectRef>
+          <a:fontRef idx="minor">
+            <a:schemeClr val="lt1"/>
+          </a:fontRef>
+        </p:style>
+        <p:txBody>
+          <a:bodyPr rtlCol="0" anchor="ctr"/>
+          <a:lstStyle/>
+          <a:p>
+            <a:pPr algn="ctr"/>
+          </a:p>
+        </p:txBody>
+      </p:sp>
+      <p:sp>
+        <p:nvSpPr>
+          <p:cNvPr id="4" name="TextBox 3"/>
           <p:cNvSpPr txBox="1"/>
           <p:nvPr/>
         </p:nvSpPr>
         <p:spPr>
           <a:xfrm>
-            <a:off x="711200" y="457200"/>
-            <a:ext cx="10769600" cy="228600"/>
+            <a:off x="609600" y="444500"/>
+            <a:ext cx="10972800" cy="279400"/>
           </a:xfrm>
           <a:prstGeom prst="rect">
             <a:avLst/>
@@ -5622,7 +5856,7 @@
               </a:spcAft>
               <a:defRPr sz="1300" b="1">
                 <a:solidFill>
-                  <a:srgbClr val="626773"/>
+                  <a:srgbClr val="B7BFCC"/>
                 </a:solidFill>
                 <a:latin typeface="Arial"/>
               </a:defRPr>
@@ -5635,20 +5869,20 @@
       </p:sp>
       <p:sp>
         <p:nvSpPr>
-          <p:cNvPr id="4" name="Rectangle 3"/>
+          <p:cNvPr id="5" name="Rectangle 4"/>
           <p:cNvSpPr/>
           <p:nvPr/>
         </p:nvSpPr>
         <p:spPr>
           <a:xfrm>
-            <a:off x="711200" y="876300"/>
-            <a:ext cx="622300" cy="50800"/>
+            <a:off x="609600" y="876300"/>
+            <a:ext cx="685800" cy="50800"/>
           </a:xfrm>
           <a:prstGeom prst="rect">
             <a:avLst/>
           </a:prstGeom>
           <a:solidFill>
-            <a:srgbClr val="E55024"/>
+            <a:srgbClr val="FF885D"/>
           </a:solidFill>
           <a:ln>
             <a:noFill/>
@@ -5678,14 +5912,14 @@
       </p:sp>
       <p:sp>
         <p:nvSpPr>
-          <p:cNvPr id="5" name="TextBox 4"/>
+          <p:cNvPr id="6" name="TextBox 5"/>
           <p:cNvSpPr txBox="1"/>
           <p:nvPr/>
         </p:nvSpPr>
         <p:spPr>
           <a:xfrm>
-            <a:off x="685800" y="1257300"/>
-            <a:ext cx="10795000" cy="1168400"/>
+            <a:off x="584200" y="1206500"/>
+            <a:ext cx="10998200" cy="1130300"/>
           </a:xfrm>
           <a:prstGeom prst="rect">
             <a:avLst/>
@@ -5707,7 +5941,7 @@
               </a:spcAft>
               <a:defRPr sz="3600" b="1">
                 <a:solidFill>
-                  <a:srgbClr val="191B20"/>
+                  <a:srgbClr val="F5F6FA"/>
                 </a:solidFill>
                 <a:latin typeface="Arial"/>
               </a:defRPr>
@@ -5720,14 +5954,57 @@
       </p:sp>
       <p:sp>
         <p:nvSpPr>
-          <p:cNvPr id="6" name="TextBox 5"/>
+          <p:cNvPr id="7" name="Rectangle 6"/>
+          <p:cNvSpPr/>
+          <p:nvPr/>
+        </p:nvSpPr>
+        <p:spPr>
+          <a:xfrm>
+            <a:off x="609600" y="2209800"/>
+            <a:ext cx="609600" cy="482600"/>
+          </a:xfrm>
+          <a:prstGeom prst="rect">
+            <a:avLst/>
+          </a:prstGeom>
+          <a:solidFill>
+            <a:srgbClr val="1D222C"/>
+          </a:solidFill>
+          <a:ln>
+            <a:noFill/>
+          </a:ln>
+        </p:spPr>
+        <p:style>
+          <a:lnRef idx="1">
+            <a:schemeClr val="accent1"/>
+          </a:lnRef>
+          <a:fillRef idx="3">
+            <a:schemeClr val="accent1"/>
+          </a:fillRef>
+          <a:effectRef idx="2">
+            <a:schemeClr val="accent1"/>
+          </a:effectRef>
+          <a:fontRef idx="minor">
+            <a:schemeClr val="lt1"/>
+          </a:fontRef>
+        </p:style>
+        <p:txBody>
+          <a:bodyPr rtlCol="0" anchor="ctr"/>
+          <a:lstStyle/>
+          <a:p>
+            <a:pPr algn="ctr"/>
+          </a:p>
+        </p:txBody>
+      </p:sp>
+      <p:sp>
+        <p:nvSpPr>
+          <p:cNvPr id="8" name="TextBox 7"/>
           <p:cNvSpPr txBox="1"/>
           <p:nvPr/>
         </p:nvSpPr>
         <p:spPr>
           <a:xfrm>
-            <a:off x="711200" y="2146300"/>
-            <a:ext cx="482600" cy="355600"/>
+            <a:off x="736600" y="2286000"/>
+            <a:ext cx="482600" cy="368300"/>
           </a:xfrm>
           <a:prstGeom prst="rect">
             <a:avLst/>
@@ -5742,14 +6019,14 @@
           <a:p>
             <a:pPr>
               <a:lnSpc>
-                <a:spcPts val="2713"/>
+                <a:spcPts val="2477"/>
               </a:lnSpc>
               <a:spcAft>
                 <a:spcPts val="0"/>
               </a:spcAft>
-              <a:defRPr sz="2300" b="1">
+              <a:defRPr sz="2100" b="1">
                 <a:solidFill>
-                  <a:srgbClr val="E55024"/>
+                  <a:srgbClr val="FF885D"/>
                 </a:solidFill>
                 <a:latin typeface="Arial"/>
               </a:defRPr>
@@ -5762,14 +6039,14 @@
       </p:sp>
       <p:sp>
         <p:nvSpPr>
-          <p:cNvPr id="7" name="TextBox 6"/>
+          <p:cNvPr id="9" name="TextBox 8"/>
           <p:cNvSpPr txBox="1"/>
           <p:nvPr/>
         </p:nvSpPr>
         <p:spPr>
           <a:xfrm>
-            <a:off x="1346200" y="2146300"/>
-            <a:ext cx="3479800" cy="685800"/>
+            <a:off x="1422400" y="2247900"/>
+            <a:ext cx="3403600" cy="685800"/>
           </a:xfrm>
           <a:prstGeom prst="rect">
             <a:avLst/>
@@ -5791,7 +6068,7 @@
               </a:spcAft>
               <a:defRPr sz="2400" b="1">
                 <a:solidFill>
-                  <a:srgbClr val="191B20"/>
+                  <a:srgbClr val="F5F6FA"/>
                 </a:solidFill>
                 <a:latin typeface="Arial"/>
               </a:defRPr>
@@ -5804,13 +6081,13 @@
       </p:sp>
       <p:sp>
         <p:nvSpPr>
-          <p:cNvPr id="8" name="TextBox 7"/>
+          <p:cNvPr id="10" name="TextBox 9"/>
           <p:cNvSpPr txBox="1"/>
           <p:nvPr/>
         </p:nvSpPr>
         <p:spPr>
           <a:xfrm>
-            <a:off x="4965700" y="2171700"/>
+            <a:off x="4965700" y="2273300"/>
             <a:ext cx="6515100" cy="698500"/>
           </a:xfrm>
           <a:prstGeom prst="rect">
@@ -5833,7 +6110,7 @@
               </a:spcAft>
               <a:defRPr sz="2300" b="0">
                 <a:solidFill>
-                  <a:srgbClr val="626773"/>
+                  <a:srgbClr val="B7BFCC"/>
                 </a:solidFill>
                 <a:latin typeface="Arial"/>
               </a:defRPr>
@@ -5846,14 +6123,57 @@
       </p:sp>
       <p:sp>
         <p:nvSpPr>
-          <p:cNvPr id="9" name="TextBox 8"/>
+          <p:cNvPr id="11" name="Rectangle 10"/>
+          <p:cNvSpPr/>
+          <p:nvPr/>
+        </p:nvSpPr>
+        <p:spPr>
+          <a:xfrm>
+            <a:off x="609600" y="3035300"/>
+            <a:ext cx="609600" cy="482600"/>
+          </a:xfrm>
+          <a:prstGeom prst="rect">
+            <a:avLst/>
+          </a:prstGeom>
+          <a:solidFill>
+            <a:srgbClr val="1D222C"/>
+          </a:solidFill>
+          <a:ln>
+            <a:noFill/>
+          </a:ln>
+        </p:spPr>
+        <p:style>
+          <a:lnRef idx="1">
+            <a:schemeClr val="accent1"/>
+          </a:lnRef>
+          <a:fillRef idx="3">
+            <a:schemeClr val="accent1"/>
+          </a:fillRef>
+          <a:effectRef idx="2">
+            <a:schemeClr val="accent1"/>
+          </a:effectRef>
+          <a:fontRef idx="minor">
+            <a:schemeClr val="lt1"/>
+          </a:fontRef>
+        </p:style>
+        <p:txBody>
+          <a:bodyPr rtlCol="0" anchor="ctr"/>
+          <a:lstStyle/>
+          <a:p>
+            <a:pPr algn="ctr"/>
+          </a:p>
+        </p:txBody>
+      </p:sp>
+      <p:sp>
+        <p:nvSpPr>
+          <p:cNvPr id="12" name="TextBox 11"/>
           <p:cNvSpPr txBox="1"/>
           <p:nvPr/>
         </p:nvSpPr>
         <p:spPr>
           <a:xfrm>
-            <a:off x="711200" y="2971800"/>
-            <a:ext cx="482600" cy="355600"/>
+            <a:off x="736600" y="3111500"/>
+            <a:ext cx="482600" cy="368300"/>
           </a:xfrm>
           <a:prstGeom prst="rect">
             <a:avLst/>
@@ -5868,14 +6188,14 @@
           <a:p>
             <a:pPr>
               <a:lnSpc>
-                <a:spcPts val="2713"/>
+                <a:spcPts val="2477"/>
               </a:lnSpc>
               <a:spcAft>
                 <a:spcPts val="0"/>
               </a:spcAft>
-              <a:defRPr sz="2300" b="1">
+              <a:defRPr sz="2100" b="1">
                 <a:solidFill>
-                  <a:srgbClr val="E55024"/>
+                  <a:srgbClr val="FF885D"/>
                 </a:solidFill>
                 <a:latin typeface="Arial"/>
               </a:defRPr>
@@ -5888,14 +6208,14 @@
       </p:sp>
       <p:sp>
         <p:nvSpPr>
-          <p:cNvPr id="10" name="TextBox 9"/>
+          <p:cNvPr id="13" name="TextBox 12"/>
           <p:cNvSpPr txBox="1"/>
           <p:nvPr/>
         </p:nvSpPr>
         <p:spPr>
           <a:xfrm>
-            <a:off x="1346200" y="2971800"/>
-            <a:ext cx="3479800" cy="685800"/>
+            <a:off x="1422400" y="3073400"/>
+            <a:ext cx="3403600" cy="685800"/>
           </a:xfrm>
           <a:prstGeom prst="rect">
             <a:avLst/>
@@ -5917,7 +6237,7 @@
               </a:spcAft>
               <a:defRPr sz="2400" b="1">
                 <a:solidFill>
-                  <a:srgbClr val="191B20"/>
+                  <a:srgbClr val="F5F6FA"/>
                 </a:solidFill>
                 <a:latin typeface="Arial"/>
               </a:defRPr>
@@ -5930,13 +6250,13 @@
       </p:sp>
       <p:sp>
         <p:nvSpPr>
-          <p:cNvPr id="11" name="TextBox 10"/>
+          <p:cNvPr id="14" name="TextBox 13"/>
           <p:cNvSpPr txBox="1"/>
           <p:nvPr/>
         </p:nvSpPr>
         <p:spPr>
           <a:xfrm>
-            <a:off x="4965700" y="2997200"/>
+            <a:off x="4965700" y="3098800"/>
             <a:ext cx="6515100" cy="698500"/>
           </a:xfrm>
           <a:prstGeom prst="rect">
@@ -5959,7 +6279,7 @@
               </a:spcAft>
               <a:defRPr sz="2300" b="0">
                 <a:solidFill>
-                  <a:srgbClr val="626773"/>
+                  <a:srgbClr val="B7BFCC"/>
                 </a:solidFill>
                 <a:latin typeface="Arial"/>
               </a:defRPr>
@@ -5972,14 +6292,57 @@
       </p:sp>
       <p:sp>
         <p:nvSpPr>
-          <p:cNvPr id="12" name="TextBox 11"/>
+          <p:cNvPr id="15" name="Rectangle 14"/>
+          <p:cNvSpPr/>
+          <p:nvPr/>
+        </p:nvSpPr>
+        <p:spPr>
+          <a:xfrm>
+            <a:off x="609600" y="3860800"/>
+            <a:ext cx="609600" cy="482600"/>
+          </a:xfrm>
+          <a:prstGeom prst="rect">
+            <a:avLst/>
+          </a:prstGeom>
+          <a:solidFill>
+            <a:srgbClr val="1D222C"/>
+          </a:solidFill>
+          <a:ln>
+            <a:noFill/>
+          </a:ln>
+        </p:spPr>
+        <p:style>
+          <a:lnRef idx="1">
+            <a:schemeClr val="accent1"/>
+          </a:lnRef>
+          <a:fillRef idx="3">
+            <a:schemeClr val="accent1"/>
+          </a:fillRef>
+          <a:effectRef idx="2">
+            <a:schemeClr val="accent1"/>
+          </a:effectRef>
+          <a:fontRef idx="minor">
+            <a:schemeClr val="lt1"/>
+          </a:fontRef>
+        </p:style>
+        <p:txBody>
+          <a:bodyPr rtlCol="0" anchor="ctr"/>
+          <a:lstStyle/>
+          <a:p>
+            <a:pPr algn="ctr"/>
+          </a:p>
+        </p:txBody>
+      </p:sp>
+      <p:sp>
+        <p:nvSpPr>
+          <p:cNvPr id="16" name="TextBox 15"/>
           <p:cNvSpPr txBox="1"/>
           <p:nvPr/>
         </p:nvSpPr>
         <p:spPr>
           <a:xfrm>
-            <a:off x="711200" y="3797300"/>
-            <a:ext cx="482600" cy="355600"/>
+            <a:off x="736600" y="3937000"/>
+            <a:ext cx="482600" cy="368300"/>
           </a:xfrm>
           <a:prstGeom prst="rect">
             <a:avLst/>
@@ -5994,14 +6357,14 @@
           <a:p>
             <a:pPr>
               <a:lnSpc>
-                <a:spcPts val="2713"/>
+                <a:spcPts val="2477"/>
               </a:lnSpc>
               <a:spcAft>
                 <a:spcPts val="0"/>
               </a:spcAft>
-              <a:defRPr sz="2300" b="1">
+              <a:defRPr sz="2100" b="1">
                 <a:solidFill>
-                  <a:srgbClr val="E55024"/>
+                  <a:srgbClr val="FF885D"/>
                 </a:solidFill>
                 <a:latin typeface="Arial"/>
               </a:defRPr>
@@ -6014,14 +6377,14 @@
       </p:sp>
       <p:sp>
         <p:nvSpPr>
-          <p:cNvPr id="13" name="TextBox 12"/>
+          <p:cNvPr id="17" name="TextBox 16"/>
           <p:cNvSpPr txBox="1"/>
           <p:nvPr/>
         </p:nvSpPr>
         <p:spPr>
           <a:xfrm>
-            <a:off x="1346200" y="3797300"/>
-            <a:ext cx="3479800" cy="685800"/>
+            <a:off x="1422400" y="3898900"/>
+            <a:ext cx="3403600" cy="685800"/>
           </a:xfrm>
           <a:prstGeom prst="rect">
             <a:avLst/>
@@ -6043,7 +6406,7 @@
               </a:spcAft>
               <a:defRPr sz="2400" b="1">
                 <a:solidFill>
-                  <a:srgbClr val="191B20"/>
+                  <a:srgbClr val="F5F6FA"/>
                 </a:solidFill>
                 <a:latin typeface="Arial"/>
               </a:defRPr>
@@ -6056,13 +6419,13 @@
       </p:sp>
       <p:sp>
         <p:nvSpPr>
-          <p:cNvPr id="14" name="TextBox 13"/>
+          <p:cNvPr id="18" name="TextBox 17"/>
           <p:cNvSpPr txBox="1"/>
           <p:nvPr/>
         </p:nvSpPr>
         <p:spPr>
           <a:xfrm>
-            <a:off x="4965700" y="3822700"/>
+            <a:off x="4965700" y="3924300"/>
             <a:ext cx="6515100" cy="698500"/>
           </a:xfrm>
           <a:prstGeom prst="rect">
@@ -6085,7 +6448,7 @@
               </a:spcAft>
               <a:defRPr sz="2300" b="0">
                 <a:solidFill>
-                  <a:srgbClr val="626773"/>
+                  <a:srgbClr val="B7BFCC"/>
                 </a:solidFill>
                 <a:latin typeface="Arial"/>
               </a:defRPr>
@@ -6098,14 +6461,57 @@
       </p:sp>
       <p:sp>
         <p:nvSpPr>
-          <p:cNvPr id="15" name="TextBox 14"/>
+          <p:cNvPr id="19" name="Rectangle 18"/>
+          <p:cNvSpPr/>
+          <p:nvPr/>
+        </p:nvSpPr>
+        <p:spPr>
+          <a:xfrm>
+            <a:off x="609600" y="4686300"/>
+            <a:ext cx="609600" cy="482600"/>
+          </a:xfrm>
+          <a:prstGeom prst="rect">
+            <a:avLst/>
+          </a:prstGeom>
+          <a:solidFill>
+            <a:srgbClr val="1D222C"/>
+          </a:solidFill>
+          <a:ln>
+            <a:noFill/>
+          </a:ln>
+        </p:spPr>
+        <p:style>
+          <a:lnRef idx="1">
+            <a:schemeClr val="accent1"/>
+          </a:lnRef>
+          <a:fillRef idx="3">
+            <a:schemeClr val="accent1"/>
+          </a:fillRef>
+          <a:effectRef idx="2">
+            <a:schemeClr val="accent1"/>
+          </a:effectRef>
+          <a:fontRef idx="minor">
+            <a:schemeClr val="lt1"/>
+          </a:fontRef>
+        </p:style>
+        <p:txBody>
+          <a:bodyPr rtlCol="0" anchor="ctr"/>
+          <a:lstStyle/>
+          <a:p>
+            <a:pPr algn="ctr"/>
+          </a:p>
+        </p:txBody>
+      </p:sp>
+      <p:sp>
+        <p:nvSpPr>
+          <p:cNvPr id="20" name="TextBox 19"/>
           <p:cNvSpPr txBox="1"/>
           <p:nvPr/>
         </p:nvSpPr>
         <p:spPr>
           <a:xfrm>
-            <a:off x="711200" y="4622800"/>
-            <a:ext cx="482600" cy="355600"/>
+            <a:off x="736600" y="4762500"/>
+            <a:ext cx="482600" cy="368300"/>
           </a:xfrm>
           <a:prstGeom prst="rect">
             <a:avLst/>
@@ -6120,14 +6526,14 @@
           <a:p>
             <a:pPr>
               <a:lnSpc>
-                <a:spcPts val="2713"/>
+                <a:spcPts val="2477"/>
               </a:lnSpc>
               <a:spcAft>
                 <a:spcPts val="0"/>
               </a:spcAft>
-              <a:defRPr sz="2300" b="1">
+              <a:defRPr sz="2100" b="1">
                 <a:solidFill>
-                  <a:srgbClr val="E55024"/>
+                  <a:srgbClr val="FF885D"/>
                 </a:solidFill>
                 <a:latin typeface="Arial"/>
               </a:defRPr>
@@ -6140,14 +6546,14 @@
       </p:sp>
       <p:sp>
         <p:nvSpPr>
-          <p:cNvPr id="16" name="TextBox 15"/>
+          <p:cNvPr id="21" name="TextBox 20"/>
           <p:cNvSpPr txBox="1"/>
           <p:nvPr/>
         </p:nvSpPr>
         <p:spPr>
           <a:xfrm>
-            <a:off x="1346200" y="4622800"/>
-            <a:ext cx="3479800" cy="685800"/>
+            <a:off x="1422400" y="4724400"/>
+            <a:ext cx="3403600" cy="685800"/>
           </a:xfrm>
           <a:prstGeom prst="rect">
             <a:avLst/>
@@ -6169,7 +6575,7 @@
               </a:spcAft>
               <a:defRPr sz="2400" b="1">
                 <a:solidFill>
-                  <a:srgbClr val="191B20"/>
+                  <a:srgbClr val="F5F6FA"/>
                 </a:solidFill>
                 <a:latin typeface="Arial"/>
               </a:defRPr>
@@ -6182,13 +6588,13 @@
       </p:sp>
       <p:sp>
         <p:nvSpPr>
-          <p:cNvPr id="17" name="TextBox 16"/>
+          <p:cNvPr id="22" name="TextBox 21"/>
           <p:cNvSpPr txBox="1"/>
           <p:nvPr/>
         </p:nvSpPr>
         <p:spPr>
           <a:xfrm>
-            <a:off x="4965700" y="4648200"/>
+            <a:off x="4965700" y="4749800"/>
             <a:ext cx="6515100" cy="698500"/>
           </a:xfrm>
           <a:prstGeom prst="rect">
@@ -6211,7 +6617,7 @@
               </a:spcAft>
               <a:defRPr sz="2300" b="0">
                 <a:solidFill>
-                  <a:srgbClr val="626773"/>
+                  <a:srgbClr val="B7BFCC"/>
                 </a:solidFill>
                 <a:latin typeface="Arial"/>
               </a:defRPr>
@@ -6224,14 +6630,14 @@
       </p:sp>
       <p:sp>
         <p:nvSpPr>
-          <p:cNvPr id="18" name="TextBox 17"/>
+          <p:cNvPr id="23" name="TextBox 22"/>
           <p:cNvSpPr txBox="1"/>
           <p:nvPr/>
         </p:nvSpPr>
         <p:spPr>
           <a:xfrm>
-            <a:off x="711200" y="5473700"/>
-            <a:ext cx="10769600" cy="596900"/>
+            <a:off x="609600" y="5651500"/>
+            <a:ext cx="10972800" cy="508000"/>
           </a:xfrm>
           <a:prstGeom prst="rect">
             <a:avLst/>
@@ -6253,7 +6659,7 @@
               </a:spcAft>
               <a:defRPr sz="1800" b="0">
                 <a:solidFill>
-                  <a:srgbClr val="626773"/>
+                  <a:srgbClr val="B7BFCC"/>
                 </a:solidFill>
                 <a:latin typeface="Arial"/>
               </a:defRPr>
@@ -6266,20 +6672,20 @@
       </p:sp>
       <p:sp>
         <p:nvSpPr>
-          <p:cNvPr id="19" name="Rectangle 18"/>
+          <p:cNvPr id="24" name="Rectangle 23"/>
           <p:cNvSpPr/>
           <p:nvPr/>
         </p:nvSpPr>
         <p:spPr>
           <a:xfrm>
-            <a:off x="711200" y="6248400"/>
-            <a:ext cx="10769600" cy="12700"/>
+            <a:off x="609600" y="6273800"/>
+            <a:ext cx="10972800" cy="12700"/>
           </a:xfrm>
           <a:prstGeom prst="rect">
             <a:avLst/>
           </a:prstGeom>
           <a:solidFill>
-            <a:srgbClr val="DFE2E7"/>
+            <a:srgbClr val="3D4552"/>
           </a:solidFill>
           <a:ln>
             <a:noFill/>
@@ -6309,14 +6715,14 @@
       </p:sp>
       <p:sp>
         <p:nvSpPr>
-          <p:cNvPr id="20" name="TextBox 19"/>
+          <p:cNvPr id="25" name="TextBox 24"/>
           <p:cNvSpPr txBox="1"/>
           <p:nvPr/>
         </p:nvSpPr>
         <p:spPr>
           <a:xfrm>
-            <a:off x="711200" y="6438900"/>
-            <a:ext cx="9652000" cy="203200"/>
+            <a:off x="609600" y="6464300"/>
+            <a:ext cx="9906000" cy="203200"/>
           </a:xfrm>
           <a:prstGeom prst="rect">
             <a:avLst/>
@@ -6338,7 +6744,7 @@
               </a:spcAft>
               <a:defRPr sz="1100" b="0">
                 <a:solidFill>
-                  <a:srgbClr val="626773"/>
+                  <a:srgbClr val="B7BFCC"/>
                 </a:solidFill>
                 <a:latin typeface="Arial"/>
               </a:defRPr>
@@ -6351,14 +6757,14 @@
       </p:sp>
       <p:sp>
         <p:nvSpPr>
-          <p:cNvPr id="21" name="TextBox 20"/>
+          <p:cNvPr id="26" name="TextBox 25"/>
           <p:cNvSpPr txBox="1"/>
           <p:nvPr/>
         </p:nvSpPr>
         <p:spPr>
           <a:xfrm>
-            <a:off x="10807700" y="6413500"/>
-            <a:ext cx="673100" cy="215900"/>
+            <a:off x="10972800" y="6438900"/>
+            <a:ext cx="609600" cy="215900"/>
           </a:xfrm>
           <a:prstGeom prst="rect">
             <a:avLst/>
@@ -6380,7 +6786,7 @@
               </a:spcAft>
               <a:defRPr sz="1200" b="0">
                 <a:solidFill>
-                  <a:srgbClr val="626773"/>
+                  <a:srgbClr val="B7BFCC"/>
                 </a:solidFill>
                 <a:latin typeface="Arial"/>
               </a:defRPr>
@@ -6424,7 +6830,7 @@
             <a:avLst/>
           </a:prstGeom>
           <a:solidFill>
-            <a:srgbClr val="FFFFFF"/>
+            <a:srgbClr val="101217"/>
           </a:solidFill>
           <a:ln>
             <a:noFill/>
@@ -6454,14 +6860,57 @@
       </p:sp>
       <p:sp>
         <p:nvSpPr>
-          <p:cNvPr id="3" name="TextBox 2"/>
+          <p:cNvPr id="3" name="Rectangle 2"/>
+          <p:cNvSpPr/>
+          <p:nvPr/>
+        </p:nvSpPr>
+        <p:spPr>
+          <a:xfrm>
+            <a:off x="0" y="0"/>
+            <a:ext cx="101600" cy="6858000"/>
+          </a:xfrm>
+          <a:prstGeom prst="rect">
+            <a:avLst/>
+          </a:prstGeom>
+          <a:solidFill>
+            <a:srgbClr val="FF885D"/>
+          </a:solidFill>
+          <a:ln>
+            <a:noFill/>
+          </a:ln>
+        </p:spPr>
+        <p:style>
+          <a:lnRef idx="1">
+            <a:schemeClr val="accent1"/>
+          </a:lnRef>
+          <a:fillRef idx="3">
+            <a:schemeClr val="accent1"/>
+          </a:fillRef>
+          <a:effectRef idx="2">
+            <a:schemeClr val="accent1"/>
+          </a:effectRef>
+          <a:fontRef idx="minor">
+            <a:schemeClr val="lt1"/>
+          </a:fontRef>
+        </p:style>
+        <p:txBody>
+          <a:bodyPr rtlCol="0" anchor="ctr"/>
+          <a:lstStyle/>
+          <a:p>
+            <a:pPr algn="ctr"/>
+          </a:p>
+        </p:txBody>
+      </p:sp>
+      <p:sp>
+        <p:nvSpPr>
+          <p:cNvPr id="4" name="TextBox 3"/>
           <p:cNvSpPr txBox="1"/>
           <p:nvPr/>
         </p:nvSpPr>
         <p:spPr>
           <a:xfrm>
-            <a:off x="711200" y="457200"/>
-            <a:ext cx="10769600" cy="228600"/>
+            <a:off x="609600" y="444500"/>
+            <a:ext cx="10972800" cy="279400"/>
           </a:xfrm>
           <a:prstGeom prst="rect">
             <a:avLst/>
@@ -6483,7 +6932,7 @@
               </a:spcAft>
               <a:defRPr sz="1300" b="1">
                 <a:solidFill>
-                  <a:srgbClr val="626773"/>
+                  <a:srgbClr val="B7BFCC"/>
                 </a:solidFill>
                 <a:latin typeface="Arial"/>
               </a:defRPr>
@@ -6496,20 +6945,20 @@
       </p:sp>
       <p:sp>
         <p:nvSpPr>
-          <p:cNvPr id="4" name="Rectangle 3"/>
+          <p:cNvPr id="5" name="Rectangle 4"/>
           <p:cNvSpPr/>
           <p:nvPr/>
         </p:nvSpPr>
         <p:spPr>
           <a:xfrm>
-            <a:off x="711200" y="876300"/>
-            <a:ext cx="622300" cy="50800"/>
+            <a:off x="609600" y="876300"/>
+            <a:ext cx="685800" cy="50800"/>
           </a:xfrm>
           <a:prstGeom prst="rect">
             <a:avLst/>
           </a:prstGeom>
           <a:solidFill>
-            <a:srgbClr val="E55024"/>
+            <a:srgbClr val="FF885D"/>
           </a:solidFill>
           <a:ln>
             <a:noFill/>
@@ -6539,14 +6988,14 @@
       </p:sp>
       <p:sp>
         <p:nvSpPr>
-          <p:cNvPr id="5" name="TextBox 4"/>
+          <p:cNvPr id="6" name="TextBox 5"/>
           <p:cNvSpPr txBox="1"/>
           <p:nvPr/>
         </p:nvSpPr>
         <p:spPr>
           <a:xfrm>
-            <a:off x="685800" y="1257300"/>
-            <a:ext cx="10795000" cy="1168400"/>
+            <a:off x="584200" y="1206500"/>
+            <a:ext cx="10998200" cy="1130300"/>
           </a:xfrm>
           <a:prstGeom prst="rect">
             <a:avLst/>
@@ -6568,7 +7017,7 @@
               </a:spcAft>
               <a:defRPr sz="3600" b="1">
                 <a:solidFill>
-                  <a:srgbClr val="191B20"/>
+                  <a:srgbClr val="F5F6FA"/>
                 </a:solidFill>
                 <a:latin typeface="Arial"/>
               </a:defRPr>
@@ -6581,14 +7030,57 @@
       </p:sp>
       <p:sp>
         <p:nvSpPr>
-          <p:cNvPr id="6" name="TextBox 5"/>
+          <p:cNvPr id="7" name="Rectangle 6"/>
+          <p:cNvSpPr/>
+          <p:nvPr/>
+        </p:nvSpPr>
+        <p:spPr>
+          <a:xfrm>
+            <a:off x="609600" y="2209800"/>
+            <a:ext cx="609600" cy="482600"/>
+          </a:xfrm>
+          <a:prstGeom prst="rect">
+            <a:avLst/>
+          </a:prstGeom>
+          <a:solidFill>
+            <a:srgbClr val="1D222C"/>
+          </a:solidFill>
+          <a:ln>
+            <a:noFill/>
+          </a:ln>
+        </p:spPr>
+        <p:style>
+          <a:lnRef idx="1">
+            <a:schemeClr val="accent1"/>
+          </a:lnRef>
+          <a:fillRef idx="3">
+            <a:schemeClr val="accent1"/>
+          </a:fillRef>
+          <a:effectRef idx="2">
+            <a:schemeClr val="accent1"/>
+          </a:effectRef>
+          <a:fontRef idx="minor">
+            <a:schemeClr val="lt1"/>
+          </a:fontRef>
+        </p:style>
+        <p:txBody>
+          <a:bodyPr rtlCol="0" anchor="ctr"/>
+          <a:lstStyle/>
+          <a:p>
+            <a:pPr algn="ctr"/>
+          </a:p>
+        </p:txBody>
+      </p:sp>
+      <p:sp>
+        <p:nvSpPr>
+          <p:cNvPr id="8" name="TextBox 7"/>
           <p:cNvSpPr txBox="1"/>
           <p:nvPr/>
         </p:nvSpPr>
         <p:spPr>
           <a:xfrm>
-            <a:off x="711200" y="2146300"/>
-            <a:ext cx="482600" cy="355600"/>
+            <a:off x="736600" y="2286000"/>
+            <a:ext cx="482600" cy="368300"/>
           </a:xfrm>
           <a:prstGeom prst="rect">
             <a:avLst/>
@@ -6603,14 +7095,14 @@
           <a:p>
             <a:pPr>
               <a:lnSpc>
-                <a:spcPts val="2713"/>
+                <a:spcPts val="2477"/>
               </a:lnSpc>
               <a:spcAft>
                 <a:spcPts val="0"/>
               </a:spcAft>
-              <a:defRPr sz="2300" b="1">
+              <a:defRPr sz="2100" b="1">
                 <a:solidFill>
-                  <a:srgbClr val="E55024"/>
+                  <a:srgbClr val="FF885D"/>
                 </a:solidFill>
                 <a:latin typeface="Arial"/>
               </a:defRPr>
@@ -6623,14 +7115,14 @@
       </p:sp>
       <p:sp>
         <p:nvSpPr>
-          <p:cNvPr id="7" name="TextBox 6"/>
+          <p:cNvPr id="9" name="TextBox 8"/>
           <p:cNvSpPr txBox="1"/>
           <p:nvPr/>
         </p:nvSpPr>
         <p:spPr>
           <a:xfrm>
-            <a:off x="1346200" y="2146300"/>
-            <a:ext cx="3479800" cy="685800"/>
+            <a:off x="1422400" y="2247900"/>
+            <a:ext cx="3403600" cy="685800"/>
           </a:xfrm>
           <a:prstGeom prst="rect">
             <a:avLst/>
@@ -6652,7 +7144,7 @@
               </a:spcAft>
               <a:defRPr sz="2400" b="1">
                 <a:solidFill>
-                  <a:srgbClr val="191B20"/>
+                  <a:srgbClr val="F5F6FA"/>
                 </a:solidFill>
                 <a:latin typeface="Arial"/>
               </a:defRPr>
@@ -6665,13 +7157,13 @@
       </p:sp>
       <p:sp>
         <p:nvSpPr>
-          <p:cNvPr id="8" name="TextBox 7"/>
+          <p:cNvPr id="10" name="TextBox 9"/>
           <p:cNvSpPr txBox="1"/>
           <p:nvPr/>
         </p:nvSpPr>
         <p:spPr>
           <a:xfrm>
-            <a:off x="4965700" y="2171700"/>
+            <a:off x="4965700" y="2273300"/>
             <a:ext cx="6515100" cy="698500"/>
           </a:xfrm>
           <a:prstGeom prst="rect">
@@ -6694,7 +7186,7 @@
               </a:spcAft>
               <a:defRPr sz="2300" b="0">
                 <a:solidFill>
-                  <a:srgbClr val="626773"/>
+                  <a:srgbClr val="B7BFCC"/>
                 </a:solidFill>
                 <a:latin typeface="Arial"/>
               </a:defRPr>
@@ -6707,14 +7199,57 @@
       </p:sp>
       <p:sp>
         <p:nvSpPr>
-          <p:cNvPr id="9" name="TextBox 8"/>
+          <p:cNvPr id="11" name="Rectangle 10"/>
+          <p:cNvSpPr/>
+          <p:nvPr/>
+        </p:nvSpPr>
+        <p:spPr>
+          <a:xfrm>
+            <a:off x="609600" y="3035300"/>
+            <a:ext cx="609600" cy="482600"/>
+          </a:xfrm>
+          <a:prstGeom prst="rect">
+            <a:avLst/>
+          </a:prstGeom>
+          <a:solidFill>
+            <a:srgbClr val="1D222C"/>
+          </a:solidFill>
+          <a:ln>
+            <a:noFill/>
+          </a:ln>
+        </p:spPr>
+        <p:style>
+          <a:lnRef idx="1">
+            <a:schemeClr val="accent1"/>
+          </a:lnRef>
+          <a:fillRef idx="3">
+            <a:schemeClr val="accent1"/>
+          </a:fillRef>
+          <a:effectRef idx="2">
+            <a:schemeClr val="accent1"/>
+          </a:effectRef>
+          <a:fontRef idx="minor">
+            <a:schemeClr val="lt1"/>
+          </a:fontRef>
+        </p:style>
+        <p:txBody>
+          <a:bodyPr rtlCol="0" anchor="ctr"/>
+          <a:lstStyle/>
+          <a:p>
+            <a:pPr algn="ctr"/>
+          </a:p>
+        </p:txBody>
+      </p:sp>
+      <p:sp>
+        <p:nvSpPr>
+          <p:cNvPr id="12" name="TextBox 11"/>
           <p:cNvSpPr txBox="1"/>
           <p:nvPr/>
         </p:nvSpPr>
         <p:spPr>
           <a:xfrm>
-            <a:off x="711200" y="2971800"/>
-            <a:ext cx="482600" cy="355600"/>
+            <a:off x="736600" y="3111500"/>
+            <a:ext cx="482600" cy="368300"/>
           </a:xfrm>
           <a:prstGeom prst="rect">
             <a:avLst/>
@@ -6729,14 +7264,14 @@
           <a:p>
             <a:pPr>
               <a:lnSpc>
-                <a:spcPts val="2713"/>
+                <a:spcPts val="2477"/>
               </a:lnSpc>
               <a:spcAft>
                 <a:spcPts val="0"/>
               </a:spcAft>
-              <a:defRPr sz="2300" b="1">
+              <a:defRPr sz="2100" b="1">
                 <a:solidFill>
-                  <a:srgbClr val="E55024"/>
+                  <a:srgbClr val="FF885D"/>
                 </a:solidFill>
                 <a:latin typeface="Arial"/>
               </a:defRPr>
@@ -6749,14 +7284,14 @@
       </p:sp>
       <p:sp>
         <p:nvSpPr>
-          <p:cNvPr id="10" name="TextBox 9"/>
+          <p:cNvPr id="13" name="TextBox 12"/>
           <p:cNvSpPr txBox="1"/>
           <p:nvPr/>
         </p:nvSpPr>
         <p:spPr>
           <a:xfrm>
-            <a:off x="1346200" y="2971800"/>
-            <a:ext cx="3479800" cy="685800"/>
+            <a:off x="1422400" y="3073400"/>
+            <a:ext cx="3403600" cy="685800"/>
           </a:xfrm>
           <a:prstGeom prst="rect">
             <a:avLst/>
@@ -6778,7 +7313,7 @@
               </a:spcAft>
               <a:defRPr sz="2400" b="1">
                 <a:solidFill>
-                  <a:srgbClr val="191B20"/>
+                  <a:srgbClr val="F5F6FA"/>
                 </a:solidFill>
                 <a:latin typeface="Arial"/>
               </a:defRPr>
@@ -6791,13 +7326,13 @@
       </p:sp>
       <p:sp>
         <p:nvSpPr>
-          <p:cNvPr id="11" name="TextBox 10"/>
+          <p:cNvPr id="14" name="TextBox 13"/>
           <p:cNvSpPr txBox="1"/>
           <p:nvPr/>
         </p:nvSpPr>
         <p:spPr>
           <a:xfrm>
-            <a:off x="4965700" y="2997200"/>
+            <a:off x="4965700" y="3098800"/>
             <a:ext cx="6515100" cy="698500"/>
           </a:xfrm>
           <a:prstGeom prst="rect">
@@ -6820,7 +7355,7 @@
               </a:spcAft>
               <a:defRPr sz="2300" b="0">
                 <a:solidFill>
-                  <a:srgbClr val="626773"/>
+                  <a:srgbClr val="B7BFCC"/>
                 </a:solidFill>
                 <a:latin typeface="Arial"/>
               </a:defRPr>
@@ -6833,14 +7368,57 @@
       </p:sp>
       <p:sp>
         <p:nvSpPr>
-          <p:cNvPr id="12" name="TextBox 11"/>
+          <p:cNvPr id="15" name="Rectangle 14"/>
+          <p:cNvSpPr/>
+          <p:nvPr/>
+        </p:nvSpPr>
+        <p:spPr>
+          <a:xfrm>
+            <a:off x="609600" y="3860800"/>
+            <a:ext cx="609600" cy="482600"/>
+          </a:xfrm>
+          <a:prstGeom prst="rect">
+            <a:avLst/>
+          </a:prstGeom>
+          <a:solidFill>
+            <a:srgbClr val="1D222C"/>
+          </a:solidFill>
+          <a:ln>
+            <a:noFill/>
+          </a:ln>
+        </p:spPr>
+        <p:style>
+          <a:lnRef idx="1">
+            <a:schemeClr val="accent1"/>
+          </a:lnRef>
+          <a:fillRef idx="3">
+            <a:schemeClr val="accent1"/>
+          </a:fillRef>
+          <a:effectRef idx="2">
+            <a:schemeClr val="accent1"/>
+          </a:effectRef>
+          <a:fontRef idx="minor">
+            <a:schemeClr val="lt1"/>
+          </a:fontRef>
+        </p:style>
+        <p:txBody>
+          <a:bodyPr rtlCol="0" anchor="ctr"/>
+          <a:lstStyle/>
+          <a:p>
+            <a:pPr algn="ctr"/>
+          </a:p>
+        </p:txBody>
+      </p:sp>
+      <p:sp>
+        <p:nvSpPr>
+          <p:cNvPr id="16" name="TextBox 15"/>
           <p:cNvSpPr txBox="1"/>
           <p:nvPr/>
         </p:nvSpPr>
         <p:spPr>
           <a:xfrm>
-            <a:off x="711200" y="3797300"/>
-            <a:ext cx="482600" cy="355600"/>
+            <a:off x="736600" y="3937000"/>
+            <a:ext cx="482600" cy="368300"/>
           </a:xfrm>
           <a:prstGeom prst="rect">
             <a:avLst/>
@@ -6855,14 +7433,14 @@
           <a:p>
             <a:pPr>
               <a:lnSpc>
-                <a:spcPts val="2713"/>
+                <a:spcPts val="2477"/>
               </a:lnSpc>
               <a:spcAft>
                 <a:spcPts val="0"/>
               </a:spcAft>
-              <a:defRPr sz="2300" b="1">
+              <a:defRPr sz="2100" b="1">
                 <a:solidFill>
-                  <a:srgbClr val="E55024"/>
+                  <a:srgbClr val="FF885D"/>
                 </a:solidFill>
                 <a:latin typeface="Arial"/>
               </a:defRPr>
@@ -6875,14 +7453,14 @@
       </p:sp>
       <p:sp>
         <p:nvSpPr>
-          <p:cNvPr id="13" name="TextBox 12"/>
+          <p:cNvPr id="17" name="TextBox 16"/>
           <p:cNvSpPr txBox="1"/>
           <p:nvPr/>
         </p:nvSpPr>
         <p:spPr>
           <a:xfrm>
-            <a:off x="1346200" y="3797300"/>
-            <a:ext cx="3479800" cy="685800"/>
+            <a:off x="1422400" y="3898900"/>
+            <a:ext cx="3403600" cy="685800"/>
           </a:xfrm>
           <a:prstGeom prst="rect">
             <a:avLst/>
@@ -6904,7 +7482,7 @@
               </a:spcAft>
               <a:defRPr sz="2400" b="1">
                 <a:solidFill>
-                  <a:srgbClr val="191B20"/>
+                  <a:srgbClr val="F5F6FA"/>
                 </a:solidFill>
                 <a:latin typeface="Arial"/>
               </a:defRPr>
@@ -6917,13 +7495,13 @@
       </p:sp>
       <p:sp>
         <p:nvSpPr>
-          <p:cNvPr id="14" name="TextBox 13"/>
+          <p:cNvPr id="18" name="TextBox 17"/>
           <p:cNvSpPr txBox="1"/>
           <p:nvPr/>
         </p:nvSpPr>
         <p:spPr>
           <a:xfrm>
-            <a:off x="4965700" y="3822700"/>
+            <a:off x="4965700" y="3924300"/>
             <a:ext cx="6515100" cy="698500"/>
           </a:xfrm>
           <a:prstGeom prst="rect">
@@ -6946,7 +7524,7 @@
               </a:spcAft>
               <a:defRPr sz="2300" b="0">
                 <a:solidFill>
-                  <a:srgbClr val="626773"/>
+                  <a:srgbClr val="B7BFCC"/>
                 </a:solidFill>
                 <a:latin typeface="Arial"/>
               </a:defRPr>
@@ -6959,14 +7537,57 @@
       </p:sp>
       <p:sp>
         <p:nvSpPr>
-          <p:cNvPr id="15" name="TextBox 14"/>
+          <p:cNvPr id="19" name="Rectangle 18"/>
+          <p:cNvSpPr/>
+          <p:nvPr/>
+        </p:nvSpPr>
+        <p:spPr>
+          <a:xfrm>
+            <a:off x="609600" y="4686300"/>
+            <a:ext cx="609600" cy="482600"/>
+          </a:xfrm>
+          <a:prstGeom prst="rect">
+            <a:avLst/>
+          </a:prstGeom>
+          <a:solidFill>
+            <a:srgbClr val="1D222C"/>
+          </a:solidFill>
+          <a:ln>
+            <a:noFill/>
+          </a:ln>
+        </p:spPr>
+        <p:style>
+          <a:lnRef idx="1">
+            <a:schemeClr val="accent1"/>
+          </a:lnRef>
+          <a:fillRef idx="3">
+            <a:schemeClr val="accent1"/>
+          </a:fillRef>
+          <a:effectRef idx="2">
+            <a:schemeClr val="accent1"/>
+          </a:effectRef>
+          <a:fontRef idx="minor">
+            <a:schemeClr val="lt1"/>
+          </a:fontRef>
+        </p:style>
+        <p:txBody>
+          <a:bodyPr rtlCol="0" anchor="ctr"/>
+          <a:lstStyle/>
+          <a:p>
+            <a:pPr algn="ctr"/>
+          </a:p>
+        </p:txBody>
+      </p:sp>
+      <p:sp>
+        <p:nvSpPr>
+          <p:cNvPr id="20" name="TextBox 19"/>
           <p:cNvSpPr txBox="1"/>
           <p:nvPr/>
         </p:nvSpPr>
         <p:spPr>
           <a:xfrm>
-            <a:off x="711200" y="4622800"/>
-            <a:ext cx="482600" cy="355600"/>
+            <a:off x="736600" y="4762500"/>
+            <a:ext cx="482600" cy="368300"/>
           </a:xfrm>
           <a:prstGeom prst="rect">
             <a:avLst/>
@@ -6981,14 +7602,14 @@
           <a:p>
             <a:pPr>
               <a:lnSpc>
-                <a:spcPts val="2713"/>
+                <a:spcPts val="2477"/>
               </a:lnSpc>
               <a:spcAft>
                 <a:spcPts val="0"/>
               </a:spcAft>
-              <a:defRPr sz="2300" b="1">
+              <a:defRPr sz="2100" b="1">
                 <a:solidFill>
-                  <a:srgbClr val="E55024"/>
+                  <a:srgbClr val="FF885D"/>
                 </a:solidFill>
                 <a:latin typeface="Arial"/>
               </a:defRPr>
@@ -7001,14 +7622,14 @@
       </p:sp>
       <p:sp>
         <p:nvSpPr>
-          <p:cNvPr id="16" name="TextBox 15"/>
+          <p:cNvPr id="21" name="TextBox 20"/>
           <p:cNvSpPr txBox="1"/>
           <p:nvPr/>
         </p:nvSpPr>
         <p:spPr>
           <a:xfrm>
-            <a:off x="1346200" y="4622800"/>
-            <a:ext cx="3479800" cy="685800"/>
+            <a:off x="1422400" y="4724400"/>
+            <a:ext cx="3403600" cy="685800"/>
           </a:xfrm>
           <a:prstGeom prst="rect">
             <a:avLst/>
@@ -7030,7 +7651,7 @@
               </a:spcAft>
               <a:defRPr sz="2400" b="1">
                 <a:solidFill>
-                  <a:srgbClr val="191B20"/>
+                  <a:srgbClr val="F5F6FA"/>
                 </a:solidFill>
                 <a:latin typeface="Arial"/>
               </a:defRPr>
@@ -7043,13 +7664,13 @@
       </p:sp>
       <p:sp>
         <p:nvSpPr>
-          <p:cNvPr id="17" name="TextBox 16"/>
+          <p:cNvPr id="22" name="TextBox 21"/>
           <p:cNvSpPr txBox="1"/>
           <p:nvPr/>
         </p:nvSpPr>
         <p:spPr>
           <a:xfrm>
-            <a:off x="4965700" y="4648200"/>
+            <a:off x="4965700" y="4749800"/>
             <a:ext cx="6515100" cy="698500"/>
           </a:xfrm>
           <a:prstGeom prst="rect">
@@ -7072,7 +7693,7 @@
               </a:spcAft>
               <a:defRPr sz="2300" b="0">
                 <a:solidFill>
-                  <a:srgbClr val="626773"/>
+                  <a:srgbClr val="B7BFCC"/>
                 </a:solidFill>
                 <a:latin typeface="Arial"/>
               </a:defRPr>
@@ -7085,14 +7706,14 @@
       </p:sp>
       <p:sp>
         <p:nvSpPr>
-          <p:cNvPr id="18" name="TextBox 17"/>
+          <p:cNvPr id="23" name="TextBox 22"/>
           <p:cNvSpPr txBox="1"/>
           <p:nvPr/>
         </p:nvSpPr>
         <p:spPr>
           <a:xfrm>
-            <a:off x="711200" y="5473700"/>
-            <a:ext cx="10769600" cy="596900"/>
+            <a:off x="609600" y="5651500"/>
+            <a:ext cx="10972800" cy="508000"/>
           </a:xfrm>
           <a:prstGeom prst="rect">
             <a:avLst/>
@@ -7114,7 +7735,7 @@
               </a:spcAft>
               <a:defRPr sz="1800" b="0">
                 <a:solidFill>
-                  <a:srgbClr val="626773"/>
+                  <a:srgbClr val="B7BFCC"/>
                 </a:solidFill>
                 <a:latin typeface="Arial"/>
               </a:defRPr>
@@ -7127,20 +7748,20 @@
       </p:sp>
       <p:sp>
         <p:nvSpPr>
-          <p:cNvPr id="19" name="Rectangle 18"/>
+          <p:cNvPr id="24" name="Rectangle 23"/>
           <p:cNvSpPr/>
           <p:nvPr/>
         </p:nvSpPr>
         <p:spPr>
           <a:xfrm>
-            <a:off x="711200" y="6248400"/>
-            <a:ext cx="10769600" cy="12700"/>
+            <a:off x="609600" y="6273800"/>
+            <a:ext cx="10972800" cy="12700"/>
           </a:xfrm>
           <a:prstGeom prst="rect">
             <a:avLst/>
           </a:prstGeom>
           <a:solidFill>
-            <a:srgbClr val="DFE2E7"/>
+            <a:srgbClr val="3D4552"/>
           </a:solidFill>
           <a:ln>
             <a:noFill/>
@@ -7170,14 +7791,14 @@
       </p:sp>
       <p:sp>
         <p:nvSpPr>
-          <p:cNvPr id="20" name="TextBox 19"/>
+          <p:cNvPr id="25" name="TextBox 24"/>
           <p:cNvSpPr txBox="1"/>
           <p:nvPr/>
         </p:nvSpPr>
         <p:spPr>
           <a:xfrm>
-            <a:off x="711200" y="6438900"/>
-            <a:ext cx="9652000" cy="203200"/>
+            <a:off x="609600" y="6464300"/>
+            <a:ext cx="9906000" cy="203200"/>
           </a:xfrm>
           <a:prstGeom prst="rect">
             <a:avLst/>
@@ -7199,7 +7820,7 @@
               </a:spcAft>
               <a:defRPr sz="1100" b="0">
                 <a:solidFill>
-                  <a:srgbClr val="626773"/>
+                  <a:srgbClr val="B7BFCC"/>
                 </a:solidFill>
                 <a:latin typeface="Arial"/>
               </a:defRPr>
@@ -7212,14 +7833,14 @@
       </p:sp>
       <p:sp>
         <p:nvSpPr>
-          <p:cNvPr id="21" name="TextBox 20"/>
+          <p:cNvPr id="26" name="TextBox 25"/>
           <p:cNvSpPr txBox="1"/>
           <p:nvPr/>
         </p:nvSpPr>
         <p:spPr>
           <a:xfrm>
-            <a:off x="10807700" y="6413500"/>
-            <a:ext cx="673100" cy="215900"/>
+            <a:off x="10972800" y="6438900"/>
+            <a:ext cx="609600" cy="215900"/>
           </a:xfrm>
           <a:prstGeom prst="rect">
             <a:avLst/>
@@ -7241,7 +7862,7 @@
               </a:spcAft>
               <a:defRPr sz="1200" b="0">
                 <a:solidFill>
-                  <a:srgbClr val="626773"/>
+                  <a:srgbClr val="B7BFCC"/>
                 </a:solidFill>
                 <a:latin typeface="Arial"/>
               </a:defRPr>
@@ -7285,7 +7906,7 @@
             <a:avLst/>
           </a:prstGeom>
           <a:solidFill>
-            <a:srgbClr val="FFFFFF"/>
+            <a:srgbClr val="101217"/>
           </a:solidFill>
           <a:ln>
             <a:noFill/>
@@ -7315,14 +7936,57 @@
       </p:sp>
       <p:sp>
         <p:nvSpPr>
-          <p:cNvPr id="3" name="TextBox 2"/>
+          <p:cNvPr id="3" name="Rectangle 2"/>
+          <p:cNvSpPr/>
+          <p:nvPr/>
+        </p:nvSpPr>
+        <p:spPr>
+          <a:xfrm>
+            <a:off x="0" y="0"/>
+            <a:ext cx="101600" cy="6858000"/>
+          </a:xfrm>
+          <a:prstGeom prst="rect">
+            <a:avLst/>
+          </a:prstGeom>
+          <a:solidFill>
+            <a:srgbClr val="FF885D"/>
+          </a:solidFill>
+          <a:ln>
+            <a:noFill/>
+          </a:ln>
+        </p:spPr>
+        <p:style>
+          <a:lnRef idx="1">
+            <a:schemeClr val="accent1"/>
+          </a:lnRef>
+          <a:fillRef idx="3">
+            <a:schemeClr val="accent1"/>
+          </a:fillRef>
+          <a:effectRef idx="2">
+            <a:schemeClr val="accent1"/>
+          </a:effectRef>
+          <a:fontRef idx="minor">
+            <a:schemeClr val="lt1"/>
+          </a:fontRef>
+        </p:style>
+        <p:txBody>
+          <a:bodyPr rtlCol="0" anchor="ctr"/>
+          <a:lstStyle/>
+          <a:p>
+            <a:pPr algn="ctr"/>
+          </a:p>
+        </p:txBody>
+      </p:sp>
+      <p:sp>
+        <p:nvSpPr>
+          <p:cNvPr id="4" name="TextBox 3"/>
           <p:cNvSpPr txBox="1"/>
           <p:nvPr/>
         </p:nvSpPr>
         <p:spPr>
           <a:xfrm>
-            <a:off x="711200" y="457200"/>
-            <a:ext cx="10769600" cy="228600"/>
+            <a:off x="609600" y="444500"/>
+            <a:ext cx="10972800" cy="279400"/>
           </a:xfrm>
           <a:prstGeom prst="rect">
             <a:avLst/>
@@ -7344,7 +8008,7 @@
               </a:spcAft>
               <a:defRPr sz="1300" b="1">
                 <a:solidFill>
-                  <a:srgbClr val="626773"/>
+                  <a:srgbClr val="B7BFCC"/>
                 </a:solidFill>
                 <a:latin typeface="Arial"/>
               </a:defRPr>
@@ -7357,20 +8021,20 @@
       </p:sp>
       <p:sp>
         <p:nvSpPr>
-          <p:cNvPr id="4" name="Rectangle 3"/>
+          <p:cNvPr id="5" name="Rectangle 4"/>
           <p:cNvSpPr/>
           <p:nvPr/>
         </p:nvSpPr>
         <p:spPr>
           <a:xfrm>
-            <a:off x="711200" y="876300"/>
-            <a:ext cx="622300" cy="50800"/>
+            <a:off x="609600" y="876300"/>
+            <a:ext cx="685800" cy="50800"/>
           </a:xfrm>
           <a:prstGeom prst="rect">
             <a:avLst/>
           </a:prstGeom>
           <a:solidFill>
-            <a:srgbClr val="E55024"/>
+            <a:srgbClr val="FF885D"/>
           </a:solidFill>
           <a:ln>
             <a:noFill/>
@@ -7400,14 +8064,14 @@
       </p:sp>
       <p:sp>
         <p:nvSpPr>
-          <p:cNvPr id="5" name="TextBox 4"/>
+          <p:cNvPr id="6" name="TextBox 5"/>
           <p:cNvSpPr txBox="1"/>
           <p:nvPr/>
         </p:nvSpPr>
         <p:spPr>
           <a:xfrm>
-            <a:off x="685800" y="1257300"/>
-            <a:ext cx="10795000" cy="1168400"/>
+            <a:off x="584200" y="1206500"/>
+            <a:ext cx="10998200" cy="1130300"/>
           </a:xfrm>
           <a:prstGeom prst="rect">
             <a:avLst/>
@@ -7429,7 +8093,7 @@
               </a:spcAft>
               <a:defRPr sz="3600" b="1">
                 <a:solidFill>
-                  <a:srgbClr val="191B20"/>
+                  <a:srgbClr val="F5F6FA"/>
                 </a:solidFill>
                 <a:latin typeface="Arial"/>
               </a:defRPr>
@@ -7442,20 +8106,20 @@
       </p:sp>
       <p:sp>
         <p:nvSpPr>
-          <p:cNvPr id="6" name="Rectangle 5"/>
+          <p:cNvPr id="7" name="Rectangle 6"/>
           <p:cNvSpPr/>
           <p:nvPr/>
         </p:nvSpPr>
         <p:spPr>
           <a:xfrm>
-            <a:off x="723900" y="2273300"/>
+            <a:off x="711200" y="2336800"/>
             <a:ext cx="101600" cy="101600"/>
           </a:xfrm>
           <a:prstGeom prst="rect">
             <a:avLst/>
           </a:prstGeom>
           <a:solidFill>
-            <a:srgbClr val="E55024"/>
+            <a:srgbClr val="FF885D"/>
           </a:solidFill>
           <a:ln>
             <a:noFill/>
@@ -7485,13 +8149,13 @@
       </p:sp>
       <p:sp>
         <p:nvSpPr>
-          <p:cNvPr id="7" name="TextBox 6"/>
+          <p:cNvPr id="8" name="TextBox 7"/>
           <p:cNvSpPr txBox="1"/>
           <p:nvPr/>
         </p:nvSpPr>
         <p:spPr>
           <a:xfrm>
-            <a:off x="1066800" y="2146300"/>
+            <a:off x="1066800" y="2209800"/>
             <a:ext cx="10160000" cy="419100"/>
           </a:xfrm>
           <a:prstGeom prst="rect">
@@ -7514,7 +8178,7 @@
               </a:spcAft>
               <a:defRPr sz="2800" b="0">
                 <a:solidFill>
-                  <a:srgbClr val="191B20"/>
+                  <a:srgbClr val="F5F6FA"/>
                 </a:solidFill>
                 <a:latin typeface="Arial"/>
               </a:defRPr>
@@ -7527,20 +8191,20 @@
       </p:sp>
       <p:sp>
         <p:nvSpPr>
-          <p:cNvPr id="8" name="Rectangle 7"/>
+          <p:cNvPr id="9" name="Rectangle 8"/>
           <p:cNvSpPr/>
           <p:nvPr/>
         </p:nvSpPr>
         <p:spPr>
           <a:xfrm>
-            <a:off x="723900" y="2971800"/>
+            <a:off x="711200" y="3009900"/>
             <a:ext cx="101600" cy="101600"/>
           </a:xfrm>
           <a:prstGeom prst="rect">
             <a:avLst/>
           </a:prstGeom>
           <a:solidFill>
-            <a:srgbClr val="E55024"/>
+            <a:srgbClr val="FF885D"/>
           </a:solidFill>
           <a:ln>
             <a:noFill/>
@@ -7570,13 +8234,13 @@
       </p:sp>
       <p:sp>
         <p:nvSpPr>
-          <p:cNvPr id="9" name="TextBox 8"/>
+          <p:cNvPr id="10" name="TextBox 9"/>
           <p:cNvSpPr txBox="1"/>
           <p:nvPr/>
         </p:nvSpPr>
         <p:spPr>
           <a:xfrm>
-            <a:off x="1066800" y="2844800"/>
+            <a:off x="1066800" y="2882900"/>
             <a:ext cx="10160000" cy="419100"/>
           </a:xfrm>
           <a:prstGeom prst="rect">
@@ -7599,7 +8263,7 @@
               </a:spcAft>
               <a:defRPr sz="2800" b="0">
                 <a:solidFill>
-                  <a:srgbClr val="191B20"/>
+                  <a:srgbClr val="F5F6FA"/>
                 </a:solidFill>
                 <a:latin typeface="Arial"/>
               </a:defRPr>
@@ -7612,20 +8276,20 @@
       </p:sp>
       <p:sp>
         <p:nvSpPr>
-          <p:cNvPr id="10" name="Rectangle 9"/>
+          <p:cNvPr id="11" name="Rectangle 10"/>
           <p:cNvSpPr/>
           <p:nvPr/>
         </p:nvSpPr>
         <p:spPr>
           <a:xfrm>
-            <a:off x="723900" y="3670300"/>
+            <a:off x="711200" y="3683000"/>
             <a:ext cx="101600" cy="101600"/>
           </a:xfrm>
           <a:prstGeom prst="rect">
             <a:avLst/>
           </a:prstGeom>
           <a:solidFill>
-            <a:srgbClr val="E55024"/>
+            <a:srgbClr val="FF885D"/>
           </a:solidFill>
           <a:ln>
             <a:noFill/>
@@ -7655,13 +8319,13 @@
       </p:sp>
       <p:sp>
         <p:nvSpPr>
-          <p:cNvPr id="11" name="TextBox 10"/>
+          <p:cNvPr id="12" name="TextBox 11"/>
           <p:cNvSpPr txBox="1"/>
           <p:nvPr/>
         </p:nvSpPr>
         <p:spPr>
           <a:xfrm>
-            <a:off x="1066800" y="3543300"/>
+            <a:off x="1066800" y="3556000"/>
             <a:ext cx="10160000" cy="419100"/>
           </a:xfrm>
           <a:prstGeom prst="rect">
@@ -7684,7 +8348,7 @@
               </a:spcAft>
               <a:defRPr sz="2800" b="0">
                 <a:solidFill>
-                  <a:srgbClr val="191B20"/>
+                  <a:srgbClr val="F5F6FA"/>
                 </a:solidFill>
                 <a:latin typeface="Arial"/>
               </a:defRPr>
@@ -7697,20 +8361,20 @@
       </p:sp>
       <p:sp>
         <p:nvSpPr>
-          <p:cNvPr id="12" name="Rectangle 11"/>
+          <p:cNvPr id="13" name="Rectangle 12"/>
           <p:cNvSpPr/>
           <p:nvPr/>
         </p:nvSpPr>
         <p:spPr>
           <a:xfrm>
-            <a:off x="723900" y="4368800"/>
+            <a:off x="711200" y="4356100"/>
             <a:ext cx="101600" cy="101600"/>
           </a:xfrm>
           <a:prstGeom prst="rect">
             <a:avLst/>
           </a:prstGeom>
           <a:solidFill>
-            <a:srgbClr val="E55024"/>
+            <a:srgbClr val="FF885D"/>
           </a:solidFill>
           <a:ln>
             <a:noFill/>
@@ -7740,13 +8404,13 @@
       </p:sp>
       <p:sp>
         <p:nvSpPr>
-          <p:cNvPr id="13" name="TextBox 12"/>
+          <p:cNvPr id="14" name="TextBox 13"/>
           <p:cNvSpPr txBox="1"/>
           <p:nvPr/>
         </p:nvSpPr>
         <p:spPr>
           <a:xfrm>
-            <a:off x="1066800" y="4241800"/>
+            <a:off x="1066800" y="4229100"/>
             <a:ext cx="10160000" cy="419100"/>
           </a:xfrm>
           <a:prstGeom prst="rect">
@@ -7769,7 +8433,7 @@
               </a:spcAft>
               <a:defRPr sz="2800" b="0">
                 <a:solidFill>
-                  <a:srgbClr val="191B20"/>
+                  <a:srgbClr val="F5F6FA"/>
                 </a:solidFill>
                 <a:latin typeface="Arial"/>
               </a:defRPr>
@@ -7782,20 +8446,20 @@
       </p:sp>
       <p:sp>
         <p:nvSpPr>
-          <p:cNvPr id="14" name="Rectangle 13"/>
+          <p:cNvPr id="15" name="Rectangle 14"/>
           <p:cNvSpPr/>
           <p:nvPr/>
         </p:nvSpPr>
         <p:spPr>
           <a:xfrm>
-            <a:off x="711200" y="6248400"/>
-            <a:ext cx="10769600" cy="12700"/>
+            <a:off x="609600" y="6273800"/>
+            <a:ext cx="10972800" cy="12700"/>
           </a:xfrm>
           <a:prstGeom prst="rect">
             <a:avLst/>
           </a:prstGeom>
           <a:solidFill>
-            <a:srgbClr val="DFE2E7"/>
+            <a:srgbClr val="3D4552"/>
           </a:solidFill>
           <a:ln>
             <a:noFill/>
@@ -7825,14 +8489,14 @@
       </p:sp>
       <p:sp>
         <p:nvSpPr>
-          <p:cNvPr id="15" name="TextBox 14"/>
+          <p:cNvPr id="16" name="TextBox 15"/>
           <p:cNvSpPr txBox="1"/>
           <p:nvPr/>
         </p:nvSpPr>
         <p:spPr>
           <a:xfrm>
-            <a:off x="711200" y="6438900"/>
-            <a:ext cx="9652000" cy="203200"/>
+            <a:off x="609600" y="6464300"/>
+            <a:ext cx="9906000" cy="203200"/>
           </a:xfrm>
           <a:prstGeom prst="rect">
             <a:avLst/>
@@ -7854,7 +8518,7 @@
               </a:spcAft>
               <a:defRPr sz="1100" b="0">
                 <a:solidFill>
-                  <a:srgbClr val="626773"/>
+                  <a:srgbClr val="B7BFCC"/>
                 </a:solidFill>
                 <a:latin typeface="Arial"/>
               </a:defRPr>
@@ -7867,14 +8531,14 @@
       </p:sp>
       <p:sp>
         <p:nvSpPr>
-          <p:cNvPr id="16" name="TextBox 15"/>
+          <p:cNvPr id="17" name="TextBox 16"/>
           <p:cNvSpPr txBox="1"/>
           <p:nvPr/>
         </p:nvSpPr>
         <p:spPr>
           <a:xfrm>
-            <a:off x="10807700" y="6413500"/>
-            <a:ext cx="673100" cy="215900"/>
+            <a:off x="10972800" y="6438900"/>
+            <a:ext cx="609600" cy="215900"/>
           </a:xfrm>
           <a:prstGeom prst="rect">
             <a:avLst/>
@@ -7896,7 +8560,7 @@
               </a:spcAft>
               <a:defRPr sz="1200" b="0">
                 <a:solidFill>
-                  <a:srgbClr val="626773"/>
+                  <a:srgbClr val="B7BFCC"/>
                 </a:solidFill>
                 <a:latin typeface="Arial"/>
               </a:defRPr>

</xml_diff>